<commit_message>
novo digital assets aug 2026
</commit_message>
<xml_diff>
--- a/Digital_Assets_&_Crypto_Risk_Outlook_July_and_August_2026.pptx
+++ b/Digital_Assets_&_Crypto_Risk_Outlook_July_and_August_2026.pptx
@@ -113,7 +113,7 @@
 </p:presentation>
 </file>
 
-<file path=ppt/charts/chart324.xml><?xml version="1.0" encoding="utf-8"?>
+<file path=ppt/charts/chart435.xml><?xml version="1.0" encoding="utf-8"?>
 <c:chartSpace xmlns:c="http://schemas.openxmlformats.org/drawingml/2006/chart" xmlns:a="http://schemas.openxmlformats.org/drawingml/2006/main" xmlns:r="http://schemas.openxmlformats.org/officeDocument/2006/relationships">
   <c:date1904 val="0"/>
   <c:roundedCorners val="1"/>
@@ -141,7 +141,7 @@
             <a:solidFill>
               <a:srgbClr val="00875A"/>
             </a:solidFill>
-            <a:ln w="38100" cap="flat">
+            <a:ln w="25400" cap="flat">
               <a:solidFill>
                 <a:srgbClr val="00875A"/>
               </a:solidFill>
@@ -176,8 +176,8 @@
             <c:showLeaderLines val="0"/>
           </c:dLbls>
           <c:marker>
-            <c:symbol val="circle"/>
-            <c:size val="5"/>
+            <c:symbol val="none"/>
+            <c:size val="6"/>
             <c:spPr>
               <a:solidFill>
                 <a:srgbClr val="00875A"/>
@@ -199,34 +199,34 @@
                 <c:ptCount val="10"/>
                 <c:lvl>
                   <c:pt idx="0">
-                    <c:v>Jul01</c:v>
+                    <c:v>J1</c:v>
                   </c:pt>
                   <c:pt idx="1">
-                    <c:v>Jul08</c:v>
+                    <c:v>J8</c:v>
                   </c:pt>
                   <c:pt idx="2">
-                    <c:v>Jul15</c:v>
+                    <c:v>J15</c:v>
                   </c:pt>
                   <c:pt idx="3">
-                    <c:v>Jul22</c:v>
+                    <c:v>J22</c:v>
                   </c:pt>
                   <c:pt idx="4">
-                    <c:v>Jul29</c:v>
+                    <c:v>J29</c:v>
                   </c:pt>
                   <c:pt idx="5">
-                    <c:v>Aug08</c:v>
+                    <c:v>A8</c:v>
                   </c:pt>
                   <c:pt idx="6">
-                    <c:v>Aug15</c:v>
+                    <c:v>A15</c:v>
                   </c:pt>
                   <c:pt idx="7">
-                    <c:v>Aug22</c:v>
+                    <c:v>A22</c:v>
                   </c:pt>
                   <c:pt idx="8">
-                    <c:v>Aug29</c:v>
+                    <c:v>A29</c:v>
                   </c:pt>
                   <c:pt idx="9">
-                    <c:v>Aug31</c:v>
+                    <c:v>A31</c:v>
                   </c:pt>
                 </c:lvl>
               </c:multiLvlStrCache>
@@ -291,7 +291,7 @@
             <a:solidFill>
               <a:srgbClr val="111111"/>
             </a:solidFill>
-            <a:ln w="38100" cap="flat">
+            <a:ln w="25400" cap="flat">
               <a:solidFill>
                 <a:srgbClr val="111111"/>
               </a:solidFill>
@@ -326,8 +326,8 @@
             <c:showLeaderLines val="0"/>
           </c:dLbls>
           <c:marker>
-            <c:symbol val="circle"/>
-            <c:size val="5"/>
+            <c:symbol val="none"/>
+            <c:size val="6"/>
             <c:spPr>
               <a:solidFill>
                 <a:srgbClr val="111111"/>
@@ -349,34 +349,34 @@
                 <c:ptCount val="10"/>
                 <c:lvl>
                   <c:pt idx="0">
-                    <c:v>Jul01</c:v>
+                    <c:v>J1</c:v>
                   </c:pt>
                   <c:pt idx="1">
-                    <c:v>Jul08</c:v>
+                    <c:v>J8</c:v>
                   </c:pt>
                   <c:pt idx="2">
-                    <c:v>Jul15</c:v>
+                    <c:v>J15</c:v>
                   </c:pt>
                   <c:pt idx="3">
-                    <c:v>Jul22</c:v>
+                    <c:v>J22</c:v>
                   </c:pt>
                   <c:pt idx="4">
-                    <c:v>Jul29</c:v>
+                    <c:v>J29</c:v>
                   </c:pt>
                   <c:pt idx="5">
-                    <c:v>Aug08</c:v>
+                    <c:v>A8</c:v>
                   </c:pt>
                   <c:pt idx="6">
-                    <c:v>Aug15</c:v>
+                    <c:v>A15</c:v>
                   </c:pt>
                   <c:pt idx="7">
-                    <c:v>Aug22</c:v>
+                    <c:v>A22</c:v>
                   </c:pt>
                   <c:pt idx="8">
-                    <c:v>Aug29</c:v>
+                    <c:v>A29</c:v>
                   </c:pt>
                   <c:pt idx="9">
-                    <c:v>Aug31</c:v>
+                    <c:v>A31</c:v>
                   </c:pt>
                 </c:lvl>
               </c:multiLvlStrCache>
@@ -540,26 +540,6 @@
         <a:effectLst/>
       </c:spPr>
     </c:plotArea>
-    <c:legend>
-      <c:legendPos val="t"/>
-      <c:overlay val="0"/>
-      <c:txPr>
-        <a:bodyPr/>
-        <a:lstStyle/>
-        <a:p>
-          <a:pPr>
-            <a:defRPr sz="1200">
-              <a:solidFill>
-                <a:srgbClr val="111111"/>
-              </a:solidFill>
-              <a:latin typeface="Inter"/>
-              <a:cs typeface="Inter"/>
-            </a:defRPr>
-          </a:pPr>
-          <a:endParaRPr lang="en-US"/>
-        </a:p>
-      </c:txPr>
-    </c:legend>
     <c:plotVisOnly val="1"/>
     <c:dispBlanksAs val="span"/>
   </c:chart>
@@ -576,7 +556,7 @@
 </c:chartSpace>
 </file>
 
-<file path=ppt/charts/chart325.xml><?xml version="1.0" encoding="utf-8"?>
+<file path=ppt/charts/chart436.xml><?xml version="1.0" encoding="utf-8"?>
 <c:chartSpace xmlns:c="http://schemas.openxmlformats.org/drawingml/2006/chart" xmlns:a="http://schemas.openxmlformats.org/drawingml/2006/main" xmlns:r="http://schemas.openxmlformats.org/officeDocument/2006/relationships">
   <c:date1904 val="0"/>
   <c:roundedCorners val="1"/>
@@ -610,75 +590,7 @@
           </c:spPr>
           <c:invertIfNegative val="0"/>
           <c:dLbls>
-            <c:dLbl>
-              <c:idx val="0"/>
-              <c:tx>
-                <c:rich>
-                  <a:bodyPr/>
-                  <a:lstStyle/>
-                  <a:p>
-                    <a:pPr>
-                      <a:defRPr b="0" i="0" strike="noStrike" sz="1200" u="none">
-                        <a:solidFill>
-                          <a:srgbClr val="111111"/>
-                        </a:solidFill>
-                        <a:latin typeface="Inter"/>
-                      </a:defRPr>
-                    </a:pPr>
-                    <a:r>
-                      <a:rPr lang="en-US" b="0" i="0" strike="noStrike" sz="1200" u="none">
-                        <a:solidFill>
-                          <a:srgbClr val="111111"/>
-                        </a:solidFill>
-                        <a:latin typeface="Inter"/>
-                      </a:rPr>
-                      <a:t>+31.02%</a:t>
-                    </a:r>
-                  </a:p>
-                </c:rich>
-              </c:tx>
-              <c:showLegendKey val="0"/>
-              <c:showVal val="0"/>
-              <c:showCatName val="0"/>
-              <c:showSerName val="0"/>
-              <c:showPercent val="0"/>
-              <c:showBubbleSize val="0"/>
-            </c:dLbl>
-            <c:dLbl>
-              <c:idx val="1"/>
-              <c:tx>
-                <c:rich>
-                  <a:bodyPr/>
-                  <a:lstStyle/>
-                  <a:p>
-                    <a:pPr>
-                      <a:defRPr b="0" i="0" strike="noStrike" sz="1200" u="none">
-                        <a:solidFill>
-                          <a:srgbClr val="111111"/>
-                        </a:solidFill>
-                        <a:latin typeface="Inter"/>
-                      </a:defRPr>
-                    </a:pPr>
-                    <a:r>
-                      <a:rPr lang="en-US" b="0" i="0" strike="noStrike" sz="1200" u="none">
-                        <a:solidFill>
-                          <a:srgbClr val="111111"/>
-                        </a:solidFill>
-                        <a:latin typeface="Inter"/>
-                      </a:rPr>
-                      <a:t>+53.47%</a:t>
-                    </a:r>
-                  </a:p>
-                </c:rich>
-              </c:tx>
-              <c:showLegendKey val="0"/>
-              <c:showVal val="0"/>
-              <c:showCatName val="0"/>
-              <c:showSerName val="0"/>
-              <c:showPercent val="0"/>
-              <c:showBubbleSize val="0"/>
-            </c:dLbl>
-            <c:numFmt formatCode="General" sourceLinked="0"/>
+            <c:numFmt formatCode="#,##0" sourceLinked="0"/>
             <c:txPr>
               <a:bodyPr/>
               <a:lstStyle/>
@@ -686,7 +598,7 @@
                 <a:pPr>
                   <a:defRPr b="0" i="0" strike="noStrike" sz="1200" u="none">
                     <a:solidFill>
-                      <a:srgbClr val="111111"/>
+                      <a:srgbClr val="000000"/>
                     </a:solidFill>
                     <a:latin typeface="Inter"/>
                   </a:defRPr>
@@ -694,7 +606,7 @@
               </a:p>
             </c:txPr>
             <c:showLegendKey val="0"/>
-            <c:showVal val="1"/>
+            <c:showVal val="0"/>
             <c:showCatName val="0"/>
             <c:showSerName val="0"/>
             <c:showPercent val="0"/>
@@ -734,7 +646,7 @@
           </c:val>
         </c:ser>
         <c:dLbls>
-          <c:numFmt formatCode="General" sourceLinked="0"/>
+          <c:numFmt formatCode="#,##0" sourceLinked="0"/>
           <c:txPr>
             <a:bodyPr/>
             <a:lstStyle/>
@@ -742,7 +654,7 @@
               <a:pPr>
                 <a:defRPr b="0" i="0" strike="noStrike" sz="1200" u="none">
                   <a:solidFill>
-                    <a:srgbClr val="111111"/>
+                    <a:srgbClr val="000000"/>
                   </a:solidFill>
                   <a:latin typeface="Inter"/>
                 </a:defRPr>
@@ -750,14 +662,14 @@
             </a:p>
           </c:txPr>
           <c:showLegendKey val="0"/>
-          <c:showVal val="1"/>
+          <c:showVal val="0"/>
           <c:showCatName val="0"/>
           <c:showSerName val="0"/>
           <c:showPercent val="0"/>
           <c:showBubbleSize val="0"/>
           <c:showLeaderLines val="0"/>
         </c:dLbls>
-        <c:gapWidth val="70"/>
+        <c:gapWidth val="65"/>
         <c:overlap val="0"/>
         <c:axId val="2094734554"/>
         <c:axId val="2094734552"/>
@@ -768,7 +680,7 @@
         <c:scaling>
           <c:orientation val="minMax"/>
         </c:scaling>
-        <c:delete val="0"/>
+        <c:delete val="1"/>
         <c:axPos val="l"/>
         <c:numFmt formatCode="General" sourceLinked="1"/>
         <c:majorTickMark val="out"/>
@@ -790,7 +702,7 @@
             <a:pPr>
               <a:defRPr sz="1200" b="0" i="0" u="none" strike="noStrike">
                 <a:solidFill>
-                  <a:srgbClr val="111111"/>
+                  <a:srgbClr val="000000"/>
                 </a:solidFill>
                 <a:latin typeface="Inter"/>
               </a:defRPr>
@@ -1643,8 +1555,8 @@
         </p:nvSpPr>
         <p:spPr>
           <a:xfrm>
-            <a:off x="406400" y="279400"/>
-            <a:ext cx="15443200" cy="533400"/>
+            <a:off x="406400" y="254000"/>
+            <a:ext cx="15443200" cy="584200"/>
           </a:xfrm>
           <a:prstGeom prst="rect">
             <a:avLst/>
@@ -1660,17 +1572,28 @@
               <a:buNone/>
             </a:pPr>
             <a:r>
-              <a:rPr lang="en-US" altLang="en-US" sz="3600" dirty="0">
-                <a:solidFill>
-                  <a:srgbClr val="00875A"/>
+              <a:rPr lang="en-US" altLang="en-US" sz="3800" b="1" dirty="0">
+                <a:solidFill>
+                  <a:srgbClr val="111111"/>
                 </a:solidFill>
                 <a:latin typeface="Inter" pitchFamily="34" charset="0"/>
                 <a:ea typeface="Inter" pitchFamily="34" charset="-122"/>
                 <a:cs typeface="Inter" pitchFamily="34" charset="-120"/>
               </a:rPr>
-              <a:t>Digital Assets &amp; Crypto Risk Outlook: July and August 2026</a:t>
-            </a:r>
-            <a:endParaRPr lang="en-US" sz="3600" dirty="0"/>
+              <a:t>Digital Assets &amp; Crypto Risk Outlook:</a:t>
+            </a:r>
+            <a:r>
+              <a:rPr lang="en-US" altLang="en-US" sz="3100" dirty="0">
+                <a:solidFill>
+                  <a:srgbClr val="6B7280"/>
+                </a:solidFill>
+                <a:latin typeface="Inter" pitchFamily="34" charset="0"/>
+                <a:ea typeface="Inter" pitchFamily="34" charset="-122"/>
+                <a:cs typeface="Inter" pitchFamily="34" charset="-120"/>
+              </a:rPr>
+              <a:t>July-August 2026</a:t>
+            </a:r>
+            <a:endParaRPr lang="en-US" sz="3800" dirty="0"/>
           </a:p>
         </p:txBody>
       </p:sp>
@@ -1682,8 +1605,8 @@
         </p:nvSpPr>
         <p:spPr>
           <a:xfrm>
-            <a:off x="406400" y="1016000"/>
-            <a:ext cx="63500" cy="774700"/>
+            <a:off x="406400" y="977900"/>
+            <a:ext cx="50800" cy="546100"/>
           </a:xfrm>
           <a:prstGeom prst="rect">
             <a:avLst/>
@@ -1702,8 +1625,8 @@
         </p:nvSpPr>
         <p:spPr>
           <a:xfrm>
-            <a:off x="685800" y="977900"/>
-            <a:ext cx="14833600" cy="850900"/>
+            <a:off x="622300" y="952500"/>
+            <a:ext cx="14986000" cy="596900"/>
           </a:xfrm>
           <a:prstGeom prst="rect">
             <a:avLst/>
@@ -1719,12 +1642,12 @@
           <a:p>
             <a:pPr algn="l" indent="0" marL="0">
               <a:lnSpc>
-                <a:spcPts val="2160"/>
+                <a:spcPts val="1888"/>
               </a:lnSpc>
               <a:buNone/>
             </a:pPr>
             <a:r>
-              <a:rPr lang="en-US" altLang="en-US" sz="1800" dirty="0">
+              <a:rPr lang="en-US" altLang="en-US" sz="1600" dirty="0">
                 <a:solidFill>
                   <a:srgbClr val="111111"/>
                 </a:solidFill>
@@ -1732,44 +1655,22 @@
                 <a:ea typeface="Inter" pitchFamily="34" charset="-122"/>
                 <a:cs typeface="Inter" pitchFamily="34" charset="-120"/>
               </a:rPr>
-              <a:t>July operational disruption and financial-crime enforcement were followed in August by price acceleration, settlement-network expansion and proposed United States rules. </a:t>
-            </a:r>
-            <a:r>
-              <a:rPr lang="en-US" altLang="en-US" sz="1800" b="1" dirty="0">
-                <a:solidFill>
-                  <a:srgbClr val="111111"/>
-                </a:solidFill>
-                <a:latin typeface="Inter" pitchFamily="34" charset="0"/>
-                <a:ea typeface="Inter" pitchFamily="34" charset="-122"/>
-                <a:cs typeface="Inter" pitchFamily="34" charset="-120"/>
-              </a:rPr>
-              <a:t>2LoD assessment:</a:t>
-            </a:r>
-            <a:r>
-              <a:rPr lang="en-US" altLang="en-US" sz="1800" dirty="0">
-                <a:solidFill>
-                  <a:srgbClr val="111111"/>
-                </a:solidFill>
-                <a:latin typeface="Inter" pitchFamily="34" charset="0"/>
-                <a:ea typeface="Inter" pitchFamily="34" charset="-122"/>
-                <a:cs typeface="Inter" pitchFamily="34" charset="-120"/>
-              </a:rPr>
-              <a:t> proceed only where provider recovery, fraud controls, product governance and settlement assurance operate together.</a:t>
-            </a:r>
-            <a:endParaRPr lang="en-US" sz="1800" dirty="0"/>
+              <a:t>Price acceleration, provider interruption, cross-border fraud enforcement and expanding settlement connectivity increased reliance on common market and service infrastructure. Recovery, fraud, custody, liquidity and product controls must operate as a single control framework.</a:t>
+            </a:r>
+            <a:endParaRPr lang="en-US" sz="1600" dirty="0"/>
           </a:p>
         </p:txBody>
       </p:sp>
       <p:sp>
         <p:nvSpPr>
-          <p:cNvPr id="5" name="column-divider-left"/>
-          <p:cNvSpPr/>
-          <p:nvPr/>
-        </p:nvSpPr>
-        <p:spPr>
-          <a:xfrm>
-            <a:off x="5486400" y="2032000"/>
-            <a:ext cx="9144" cy="6781800"/>
+          <p:cNvPr id="5" name="vertical-left"/>
+          <p:cNvSpPr/>
+          <p:nvPr/>
+        </p:nvSpPr>
+        <p:spPr>
+          <a:xfrm>
+            <a:off x="5435600" y="1752600"/>
+            <a:ext cx="9144" cy="7086600"/>
           </a:xfrm>
           <a:prstGeom prst="line">
             <a:avLst/>
@@ -1784,14 +1685,14 @@
       </p:sp>
       <p:sp>
         <p:nvSpPr>
-          <p:cNvPr id="6" name="column-divider-right"/>
-          <p:cNvSpPr/>
-          <p:nvPr/>
-        </p:nvSpPr>
-        <p:spPr>
-          <a:xfrm>
-            <a:off x="10769600" y="2032000"/>
-            <a:ext cx="9144" cy="6781800"/>
+          <p:cNvPr id="6" name="vertical-right"/>
+          <p:cNvSpPr/>
+          <p:nvPr/>
+        </p:nvSpPr>
+        <p:spPr>
+          <a:xfrm>
+            <a:off x="10795000" y="1752600"/>
+            <a:ext cx="9144" cy="7086600"/>
           </a:xfrm>
           <a:prstGeom prst="line">
             <a:avLst/>
@@ -1812,8 +1713,8 @@
         </p:nvSpPr>
         <p:spPr>
           <a:xfrm>
-            <a:off x="406400" y="2082800"/>
-            <a:ext cx="4114800" cy="342900"/>
+            <a:off x="406400" y="1803400"/>
+            <a:ext cx="3810000" cy="355600"/>
           </a:xfrm>
           <a:prstGeom prst="rect">
             <a:avLst/>
@@ -1829,7 +1730,7 @@
               <a:buNone/>
             </a:pPr>
             <a:r>
-              <a:rPr lang="en-US" altLang="en-US" sz="2000" b="1" dirty="0">
+              <a:rPr lang="en-US" altLang="en-US" sz="2100" b="1" dirty="0">
                 <a:solidFill>
                   <a:srgbClr val="111111"/>
                 </a:solidFill>
@@ -1839,13 +1740,13 @@
               </a:rPr>
               <a:t>MARKET VITAL SIGNS</a:t>
             </a:r>
-            <a:endParaRPr lang="en-US" sz="2000" dirty="0"/>
+            <a:endParaRPr lang="en-US" sz="2100" dirty="0"/>
           </a:p>
         </p:txBody>
       </p:sp>
       <p:pic>
         <p:nvPicPr>
-          <p:cNvPr id="8" name="market-icon" descr="preencoded.png">    </p:cNvPr>
+          <p:cNvPr id="8" name="market-column-icon" descr="preencoded.png">    </p:cNvPr>
           <p:cNvPicPr>
             <a:picLocks noChangeAspect="1"/>
           </p:cNvPicPr>
@@ -1859,8 +1760,8 @@
         </p:blipFill>
         <p:spPr>
           <a:xfrm>
-            <a:off x="4775200" y="2057400"/>
-            <a:ext cx="330200" cy="330200"/>
+            <a:off x="4724400" y="1778000"/>
+            <a:ext cx="355600" cy="355600"/>
           </a:xfrm>
           <a:prstGeom prst="rect">
             <a:avLst/>
@@ -1869,13 +1770,13 @@
       </p:pic>
       <p:sp>
         <p:nvSpPr>
-          <p:cNvPr id="9" name="market-underline"/>
-          <p:cNvSpPr/>
-          <p:nvPr/>
-        </p:nvSpPr>
-        <p:spPr>
-          <a:xfrm>
-            <a:off x="406400" y="2514600"/>
+          <p:cNvPr id="9" name="market-rule"/>
+          <p:cNvSpPr/>
+          <p:nvPr/>
+        </p:nvSpPr>
+        <p:spPr>
+          <a:xfrm>
+            <a:off x="406400" y="2260600"/>
             <a:ext cx="4775200" cy="9144"/>
           </a:xfrm>
           <a:prstGeom prst="line">
@@ -1891,14 +1792,58 @@
       </p:sp>
       <p:sp>
         <p:nvSpPr>
-          <p:cNvPr id="10" name="market-chart-title"/>
-          <p:cNvSpPr/>
-          <p:nvPr/>
-        </p:nvSpPr>
-        <p:spPr>
-          <a:xfrm>
-            <a:off x="406400" y="2705100"/>
-            <a:ext cx="4775200" cy="215900"/>
+          <p:cNvPr id="10" name="market-divider-one"/>
+          <p:cNvSpPr/>
+          <p:nvPr/>
+        </p:nvSpPr>
+        <p:spPr>
+          <a:xfrm>
+            <a:off x="406400" y="4572000"/>
+            <a:ext cx="4775200" cy="9144"/>
+          </a:xfrm>
+          <a:prstGeom prst="line">
+            <a:avLst/>
+          </a:prstGeom>
+          <a:ln w="12700">
+            <a:solidFill>
+              <a:srgbClr val="D1D5DB"/>
+            </a:solidFill>
+            <a:prstDash val="solid"/>
+          </a:ln>
+        </p:spPr>
+      </p:sp>
+      <p:sp>
+        <p:nvSpPr>
+          <p:cNvPr id="11" name="market-divider-two"/>
+          <p:cNvSpPr/>
+          <p:nvPr/>
+        </p:nvSpPr>
+        <p:spPr>
+          <a:xfrm>
+            <a:off x="406400" y="6705600"/>
+            <a:ext cx="4775200" cy="9144"/>
+          </a:xfrm>
+          <a:prstGeom prst="line">
+            <a:avLst/>
+          </a:prstGeom>
+          <a:ln w="12700">
+            <a:solidFill>
+              <a:srgbClr val="D1D5DB"/>
+            </a:solidFill>
+            <a:prstDash val="solid"/>
+          </a:ln>
+        </p:spPr>
+      </p:sp>
+      <p:sp>
+        <p:nvSpPr>
+          <p:cNvPr id="12" name="price-title"/>
+          <p:cNvSpPr/>
+          <p:nvPr/>
+        </p:nvSpPr>
+        <p:spPr>
+          <a:xfrm>
+            <a:off x="406400" y="2451100"/>
+            <a:ext cx="4775200" cy="266700"/>
           </a:xfrm>
           <a:prstGeom prst="rect">
             <a:avLst/>
@@ -1914,7 +1859,7 @@
               <a:buNone/>
             </a:pPr>
             <a:r>
-              <a:rPr lang="en-US" altLang="en-US" sz="1200" b="1" dirty="0">
+              <a:rPr lang="en-US" altLang="en-US" sz="1700" b="1" dirty="0">
                 <a:solidFill>
                   <a:srgbClr val="111111"/>
                 </a:solidFill>
@@ -1922,32 +1867,21 @@
                 <a:ea typeface="Inter" pitchFamily="34" charset="-122"/>
                 <a:cs typeface="Inter" pitchFamily="34" charset="-120"/>
               </a:rPr>
-              <a:t>INDEXED DAILY CLOSE</a:t>
-            </a:r>
-            <a:r>
-              <a:rPr lang="en-US" altLang="en-US" sz="1200" dirty="0">
-                <a:solidFill>
-                  <a:srgbClr val="111111"/>
-                </a:solidFill>
-                <a:latin typeface="Inter" pitchFamily="34" charset="0"/>
-                <a:ea typeface="Inter" pitchFamily="34" charset="-122"/>
-                <a:cs typeface="Inter" pitchFamily="34" charset="-120"/>
-              </a:rPr>
-              <a:t> | Relative price path</a:t>
-            </a:r>
-            <a:endParaRPr lang="en-US" sz="1200" dirty="0"/>
+              <a:t>BTC &amp; ETH Price Momentum</a:t>
+            </a:r>
+            <a:endParaRPr lang="en-US" sz="1700" dirty="0"/>
           </a:p>
         </p:txBody>
       </p:sp>
       <p:graphicFrame>
         <p:nvGraphicFramePr>
-          <p:cNvPr id="11" name="market-index-chart" descr=""/>
+          <p:cNvPr id="13" name="price-mini-chart" descr=""/>
           <p:cNvGraphicFramePr/>
           <p:nvPr/>
         </p:nvGraphicFramePr>
         <p:xfrm>
-          <a:off x="406400" y="2997200"/>
-          <a:ext cx="4775200" cy="2146300"/>
+          <a:off x="406400" y="2844800"/>
+          <a:ext cx="1346200" cy="990600"/>
         </p:xfrm>
         <a:graphic xmlns:a="http://schemas.openxmlformats.org/drawingml/2006/main">
           <a:graphicData uri="http://schemas.openxmlformats.org/drawingml/2006/chart">
@@ -1957,36 +1891,14 @@
       </p:graphicFrame>
       <p:sp>
         <p:nvSpPr>
-          <p:cNvPr id="12" name="market-divider-one"/>
-          <p:cNvSpPr/>
-          <p:nvPr/>
-        </p:nvSpPr>
-        <p:spPr>
-          <a:xfrm>
-            <a:off x="406400" y="5359400"/>
-            <a:ext cx="4775200" cy="9144"/>
-          </a:xfrm>
-          <a:prstGeom prst="line">
-            <a:avLst/>
-          </a:prstGeom>
-          <a:ln w="12700">
-            <a:solidFill>
-              <a:srgbClr val="D1D5DB"/>
-            </a:solidFill>
-            <a:prstDash val="solid"/>
-          </a:ln>
-        </p:spPr>
-      </p:sp>
-      <p:sp>
-        <p:nvSpPr>
-          <p:cNvPr id="13" name="return-chart-title"/>
-          <p:cNvSpPr/>
-          <p:nvPr/>
-        </p:nvSpPr>
-        <p:spPr>
-          <a:xfrm>
-            <a:off x="406400" y="5549900"/>
-            <a:ext cx="4775200" cy="215900"/>
+          <p:cNvPr id="14" name="btc-metric"/>
+          <p:cNvSpPr/>
+          <p:nvPr/>
+        </p:nvSpPr>
+        <p:spPr>
+          <a:xfrm>
+            <a:off x="1955800" y="2806700"/>
+            <a:ext cx="3225800" cy="381000"/>
           </a:xfrm>
           <a:prstGeom prst="rect">
             <a:avLst/>
@@ -2002,7 +1914,7 @@
               <a:buNone/>
             </a:pPr>
             <a:r>
-              <a:rPr lang="en-US" altLang="en-US" sz="1200" b="1" dirty="0">
+              <a:rPr lang="en-US" altLang="en-US" sz="2500" dirty="0">
                 <a:solidFill>
                   <a:srgbClr val="111111"/>
                 </a:solidFill>
@@ -2010,32 +1922,165 @@
                 <a:ea typeface="Inter" pitchFamily="34" charset="-122"/>
                 <a:cs typeface="Inter" pitchFamily="34" charset="-120"/>
               </a:rPr>
-              <a:t>TWO-MONTH RETURN</a:t>
-            </a:r>
-            <a:r>
-              <a:rPr lang="en-US" altLang="en-US" sz="1200" dirty="0">
-                <a:solidFill>
-                  <a:srgbClr val="111111"/>
+              <a:t>BTC </a:t>
+            </a:r>
+            <a:r>
+              <a:rPr lang="en-US" altLang="en-US" sz="2500" b="1" dirty="0">
+                <a:solidFill>
+                  <a:srgbClr val="00875A"/>
                 </a:solidFill>
                 <a:latin typeface="Inter" pitchFamily="34" charset="0"/>
                 <a:ea typeface="Inter" pitchFamily="34" charset="-122"/>
                 <a:cs typeface="Inter" pitchFamily="34" charset="-120"/>
               </a:rPr>
-              <a:t> | Single venue</a:t>
-            </a:r>
-            <a:endParaRPr lang="en-US" sz="1200" dirty="0"/>
+              <a:t>+31.02%</a:t>
+            </a:r>
+            <a:endParaRPr lang="en-US" sz="2500" dirty="0"/>
+          </a:p>
+        </p:txBody>
+      </p:sp>
+      <p:sp>
+        <p:nvSpPr>
+          <p:cNvPr id="15" name="eth-metric"/>
+          <p:cNvSpPr/>
+          <p:nvPr/>
+        </p:nvSpPr>
+        <p:spPr>
+          <a:xfrm>
+            <a:off x="1955800" y="3225800"/>
+            <a:ext cx="3225800" cy="381000"/>
+          </a:xfrm>
+          <a:prstGeom prst="rect">
+            <a:avLst/>
+          </a:prstGeom>
+          <a:noFill/>
+          <a:ln/>
+        </p:spPr>
+        <p:txBody>
+          <a:bodyPr wrap="none" lIns="0" tIns="0" rIns="0" bIns="0" rtlCol="0" anchor="t"/>
+          <a:lstStyle/>
+          <a:p>
+            <a:pPr algn="l" indent="0" marL="0">
+              <a:buNone/>
+            </a:pPr>
+            <a:r>
+              <a:rPr lang="en-US" altLang="en-US" sz="2500" dirty="0">
+                <a:solidFill>
+                  <a:srgbClr val="111111"/>
+                </a:solidFill>
+                <a:latin typeface="Inter" pitchFamily="34" charset="0"/>
+                <a:ea typeface="Inter" pitchFamily="34" charset="-122"/>
+                <a:cs typeface="Inter" pitchFamily="34" charset="-120"/>
+              </a:rPr>
+              <a:t>ETH </a:t>
+            </a:r>
+            <a:r>
+              <a:rPr lang="en-US" altLang="en-US" sz="2500" b="1" dirty="0">
+                <a:solidFill>
+                  <a:srgbClr val="00875A"/>
+                </a:solidFill>
+                <a:latin typeface="Inter" pitchFamily="34" charset="0"/>
+                <a:ea typeface="Inter" pitchFamily="34" charset="-122"/>
+                <a:cs typeface="Inter" pitchFamily="34" charset="-120"/>
+              </a:rPr>
+              <a:t>+53.47%</a:t>
+            </a:r>
+            <a:endParaRPr lang="en-US" sz="2500" dirty="0"/>
+          </a:p>
+        </p:txBody>
+      </p:sp>
+      <p:sp>
+        <p:nvSpPr>
+          <p:cNvPr id="16" name="price-copy"/>
+          <p:cNvSpPr/>
+          <p:nvPr/>
+        </p:nvSpPr>
+        <p:spPr>
+          <a:xfrm>
+            <a:off x="406400" y="3987800"/>
+            <a:ext cx="4775200" cy="469900"/>
+          </a:xfrm>
+          <a:prstGeom prst="rect">
+            <a:avLst/>
+          </a:prstGeom>
+          <a:noFill/>
+          <a:ln/>
+        </p:spPr>
+        <p:txBody>
+          <a:bodyPr wrap="square" lIns="0" tIns="0" rIns="0" bIns="0" rtlCol="0" anchor="t">
+            <a:normAutofit/>
+          </a:bodyPr>
+          <a:lstStyle/>
+          <a:p>
+            <a:pPr algn="l" indent="0" marL="0">
+              <a:lnSpc>
+                <a:spcPts val="1534"/>
+              </a:lnSpc>
+              <a:buNone/>
+            </a:pPr>
+            <a:r>
+              <a:rPr lang="en-US" altLang="en-US" sz="1300" dirty="0">
+                <a:solidFill>
+                  <a:srgbClr val="111111"/>
+                </a:solidFill>
+                <a:latin typeface="Inter" pitchFamily="34" charset="0"/>
+                <a:ea typeface="Inter" pitchFamily="34" charset="-122"/>
+                <a:cs typeface="Inter" pitchFamily="34" charset="-120"/>
+              </a:rPr>
+              <a:t>BTC and ETH rose sharply across the two-month window, increasing collateral, margin, valuation and intraday liquidity demands across trading, custody and client-facing activity.</a:t>
+            </a:r>
+            <a:endParaRPr lang="en-US" sz="1300" dirty="0"/>
+          </a:p>
+        </p:txBody>
+      </p:sp>
+      <p:sp>
+        <p:nvSpPr>
+          <p:cNvPr id="17" name="dispersion-title"/>
+          <p:cNvSpPr/>
+          <p:nvPr/>
+        </p:nvSpPr>
+        <p:spPr>
+          <a:xfrm>
+            <a:off x="406400" y="4787900"/>
+            <a:ext cx="4775200" cy="266700"/>
+          </a:xfrm>
+          <a:prstGeom prst="rect">
+            <a:avLst/>
+          </a:prstGeom>
+          <a:noFill/>
+          <a:ln/>
+        </p:spPr>
+        <p:txBody>
+          <a:bodyPr wrap="none" lIns="0" tIns="0" rIns="0" bIns="0" rtlCol="0" anchor="t"/>
+          <a:lstStyle/>
+          <a:p>
+            <a:pPr algn="l" indent="0" marL="0">
+              <a:buNone/>
+            </a:pPr>
+            <a:r>
+              <a:rPr lang="en-US" altLang="en-US" sz="1700" b="1" dirty="0">
+                <a:solidFill>
+                  <a:srgbClr val="111111"/>
+                </a:solidFill>
+                <a:latin typeface="Inter" pitchFamily="34" charset="0"/>
+                <a:ea typeface="Inter" pitchFamily="34" charset="-122"/>
+                <a:cs typeface="Inter" pitchFamily="34" charset="-120"/>
+              </a:rPr>
+              <a:t>Return Dispersion &amp; Liquidity Sensitivity</a:t>
+            </a:r>
+            <a:endParaRPr lang="en-US" sz="1700" dirty="0"/>
           </a:p>
         </p:txBody>
       </p:sp>
       <p:graphicFrame>
         <p:nvGraphicFramePr>
-          <p:cNvPr id="14" name="market-return-chart" descr=""/>
+          <p:cNvPr id="18" name="return-mini-chart" descr=""/>
           <p:cNvGraphicFramePr/>
           <p:nvPr/>
         </p:nvGraphicFramePr>
         <p:xfrm>
-          <a:off x="406400" y="5816600"/>
-          <a:ext cx="4775200" cy="1117600"/>
+          <a:off x="406400" y="5245100"/>
+          <a:ext cx="1346200" cy="1041400"/>
         </p:xfrm>
         <a:graphic xmlns:a="http://schemas.openxmlformats.org/drawingml/2006/main">
           <a:graphicData uri="http://schemas.openxmlformats.org/drawingml/2006/chart">
@@ -2045,75 +2090,14 @@
       </p:graphicFrame>
       <p:sp>
         <p:nvSpPr>
-          <p:cNvPr id="15" name="market-divider-two"/>
-          <p:cNvSpPr/>
-          <p:nvPr/>
-        </p:nvSpPr>
-        <p:spPr>
-          <a:xfrm>
-            <a:off x="406400" y="7137400"/>
-            <a:ext cx="4775200" cy="9144"/>
-          </a:xfrm>
-          <a:prstGeom prst="line">
-            <a:avLst/>
-          </a:prstGeom>
-          <a:ln w="12700">
-            <a:solidFill>
-              <a:srgbClr val="D1D5DB"/>
-            </a:solidFill>
-            <a:prstDash val="solid"/>
-          </a:ln>
-        </p:spPr>
-      </p:sp>
-      <p:sp>
-        <p:nvSpPr>
-          <p:cNvPr id="16" name="market-control-title"/>
-          <p:cNvSpPr/>
-          <p:nvPr/>
-        </p:nvSpPr>
-        <p:spPr>
-          <a:xfrm>
-            <a:off x="406400" y="7340600"/>
-            <a:ext cx="4775200" cy="254000"/>
-          </a:xfrm>
-          <a:prstGeom prst="rect">
-            <a:avLst/>
-          </a:prstGeom>
-          <a:noFill/>
-          <a:ln/>
-        </p:spPr>
-        <p:txBody>
-          <a:bodyPr wrap="none" lIns="0" tIns="0" rIns="0" bIns="0" rtlCol="0" anchor="t"/>
-          <a:lstStyle/>
-          <a:p>
-            <a:pPr algn="l" indent="0" marL="0">
-              <a:buNone/>
-            </a:pPr>
-            <a:r>
-              <a:rPr lang="en-US" altLang="en-US" sz="1500" b="1" dirty="0">
-                <a:solidFill>
-                  <a:srgbClr val="111111"/>
-                </a:solidFill>
-                <a:latin typeface="Inter" pitchFamily="34" charset="0"/>
-                <a:ea typeface="Inter" pitchFamily="34" charset="-122"/>
-                <a:cs typeface="Inter" pitchFamily="34" charset="-120"/>
-              </a:rPr>
-              <a:t>Market-risk control</a:t>
-            </a:r>
-            <a:endParaRPr lang="en-US" sz="1500" dirty="0"/>
-          </a:p>
-        </p:txBody>
-      </p:sp>
-      <p:sp>
-        <p:nvSpPr>
-          <p:cNvPr id="17" name="market-control-copy"/>
-          <p:cNvSpPr/>
-          <p:nvPr/>
-        </p:nvSpPr>
-        <p:spPr>
-          <a:xfrm>
-            <a:off x="406400" y="7708900"/>
-            <a:ext cx="4775200" cy="952500"/>
+          <p:cNvPr id="19" name="dispersion-headline"/>
+          <p:cNvSpPr/>
+          <p:nvPr/>
+        </p:nvSpPr>
+        <p:spPr>
+          <a:xfrm>
+            <a:off x="1955800" y="5283200"/>
+            <a:ext cx="3225800" cy="533400"/>
           </a:xfrm>
           <a:prstGeom prst="rect">
             <a:avLst/>
@@ -2129,12 +2113,12 @@
           <a:p>
             <a:pPr algn="l" indent="0" marL="0">
               <a:lnSpc>
-                <a:spcPts val="1560"/>
+                <a:spcPts val="2205"/>
               </a:lnSpc>
               <a:buNone/>
             </a:pPr>
             <a:r>
-              <a:rPr lang="en-US" altLang="en-US" sz="1300" dirty="0">
+              <a:rPr lang="en-US" altLang="en-US" sz="2100" dirty="0">
                 <a:solidFill>
                   <a:srgbClr val="111111"/>
                 </a:solidFill>
@@ -2142,19 +2126,61 @@
                 <a:ea typeface="Inter" pitchFamily="34" charset="-122"/>
                 <a:cs typeface="Inter" pitchFamily="34" charset="-120"/>
               </a:rPr>
-              <a:t>Observed venue data shows high price sensitivity. </a:t>
-            </a:r>
-            <a:r>
-              <a:rPr lang="en-US" altLang="en-US" sz="1300" b="1" dirty="0">
-                <a:solidFill>
-                  <a:srgbClr val="111111"/>
+              <a:t>Late-August</a:t>
+            </a:r>
+            <a:endParaRPr lang="en-US" sz="2100" dirty="0"/>
+          </a:p>
+          <a:p>
+            <a:pPr algn="l" indent="0" marL="0">
+              <a:lnSpc>
+                <a:spcPts val="2205"/>
+              </a:lnSpc>
+              <a:buNone/>
+            </a:pPr>
+            <a:r>
+              <a:rPr lang="en-US" altLang="en-US" sz="2100" b="1" dirty="0">
+                <a:solidFill>
+                  <a:srgbClr val="00875A"/>
                 </a:solidFill>
                 <a:latin typeface="Inter" pitchFamily="34" charset="0"/>
                 <a:ea typeface="Inter" pitchFamily="34" charset="-122"/>
                 <a:cs typeface="Inter" pitchFamily="34" charset="-120"/>
               </a:rPr>
-              <a:t>2LoD assessment:</a:t>
-            </a:r>
+              <a:t>Acceleration</a:t>
+            </a:r>
+            <a:endParaRPr lang="en-US" sz="2100" dirty="0"/>
+          </a:p>
+        </p:txBody>
+      </p:sp>
+      <p:sp>
+        <p:nvSpPr>
+          <p:cNvPr id="20" name="dispersion-copy"/>
+          <p:cNvSpPr/>
+          <p:nvPr/>
+        </p:nvSpPr>
+        <p:spPr>
+          <a:xfrm>
+            <a:off x="1955800" y="5905500"/>
+            <a:ext cx="3225800" cy="609600"/>
+          </a:xfrm>
+          <a:prstGeom prst="rect">
+            <a:avLst/>
+          </a:prstGeom>
+          <a:noFill/>
+          <a:ln/>
+        </p:spPr>
+        <p:txBody>
+          <a:bodyPr wrap="square" lIns="0" tIns="0" rIns="0" bIns="0" rtlCol="0" anchor="t">
+            <a:normAutofit/>
+          </a:bodyPr>
+          <a:lstStyle/>
+          <a:p>
+            <a:pPr algn="l" indent="0" marL="0">
+              <a:lnSpc>
+                <a:spcPts val="1534"/>
+              </a:lnSpc>
+              <a:buNone/>
+            </a:pPr>
             <a:r>
               <a:rPr lang="en-US" altLang="en-US" sz="1300" dirty="0">
                 <a:solidFill>
@@ -2164,54 +2190,15 @@
                 <a:ea typeface="Inter" pitchFamily="34" charset="-122"/>
                 <a:cs typeface="Inter" pitchFamily="34" charset="-120"/>
               </a:rPr>
-              <a:t> sustain collateral, valuation, margin and liquidity processes through rapid client-flow changes; shared custodians and liquidity venues remain a concentration pathway.</a:t>
+              <a:t>Common market makers, custodians and liquidity venues can transmit operational and market pressure across listed and bilateral activity.</a:t>
             </a:r>
             <a:endParaRPr lang="en-US" sz="1300" dirty="0"/>
-          </a:p>
-        </p:txBody>
-      </p:sp>
-      <p:sp>
-        <p:nvSpPr>
-          <p:cNvPr id="18" name="trends-heading"/>
-          <p:cNvSpPr/>
-          <p:nvPr/>
-        </p:nvSpPr>
-        <p:spPr>
-          <a:xfrm>
-            <a:off x="5791200" y="2082800"/>
-            <a:ext cx="3810000" cy="342900"/>
-          </a:xfrm>
-          <a:prstGeom prst="rect">
-            <a:avLst/>
-          </a:prstGeom>
-          <a:noFill/>
-          <a:ln/>
-        </p:spPr>
-        <p:txBody>
-          <a:bodyPr wrap="none" lIns="0" tIns="0" rIns="0" bIns="0" rtlCol="0" anchor="t"/>
-          <a:lstStyle/>
-          <a:p>
-            <a:pPr algn="l" indent="0" marL="0">
-              <a:buNone/>
-            </a:pPr>
-            <a:r>
-              <a:rPr lang="en-US" altLang="en-US" sz="2000" b="1" dirty="0">
-                <a:solidFill>
-                  <a:srgbClr val="111111"/>
-                </a:solidFill>
-                <a:latin typeface="Inter" pitchFamily="34" charset="0"/>
-                <a:ea typeface="Inter" pitchFamily="34" charset="-122"/>
-                <a:cs typeface="Inter" pitchFamily="34" charset="-120"/>
-              </a:rPr>
-              <a:t>KEY TRENDS</a:t>
-            </a:r>
-            <a:endParaRPr lang="en-US" sz="2000" dirty="0"/>
           </a:p>
         </p:txBody>
       </p:sp>
       <p:pic>
         <p:nvPicPr>
-          <p:cNvPr id="19" name="trends-icon" descr="preencoded.png">    </p:cNvPr>
+          <p:cNvPr id="21" name="controls-icon" descr="preencoded.png">    </p:cNvPr>
           <p:cNvPicPr>
             <a:picLocks noChangeAspect="1"/>
           </p:cNvPicPr>
@@ -2225,8 +2212,8 @@
         </p:blipFill>
         <p:spPr>
           <a:xfrm>
-            <a:off x="10033000" y="2057400"/>
-            <a:ext cx="330200" cy="330200"/>
+            <a:off x="406400" y="7010400"/>
+            <a:ext cx="736600" cy="736600"/>
           </a:xfrm>
           <a:prstGeom prst="rect">
             <a:avLst/>
@@ -2235,119 +2222,14 @@
       </p:pic>
       <p:sp>
         <p:nvSpPr>
-          <p:cNvPr id="20" name="trends-underline"/>
-          <p:cNvSpPr/>
-          <p:nvPr/>
-        </p:nvSpPr>
-        <p:spPr>
-          <a:xfrm>
-            <a:off x="5791200" y="2514600"/>
-            <a:ext cx="4673600" cy="9144"/>
-          </a:xfrm>
-          <a:prstGeom prst="line">
-            <a:avLst/>
-          </a:prstGeom>
-          <a:ln w="25400">
-            <a:solidFill>
-              <a:srgbClr val="00875A"/>
-            </a:solidFill>
-            <a:prstDash val="solid"/>
-          </a:ln>
-        </p:spPr>
-      </p:sp>
-      <p:sp>
-        <p:nvSpPr>
-          <p:cNvPr id="21" name="trends-divider-one"/>
-          <p:cNvSpPr/>
-          <p:nvPr/>
-        </p:nvSpPr>
-        <p:spPr>
-          <a:xfrm>
-            <a:off x="5791200" y="4572000"/>
-            <a:ext cx="4673600" cy="9144"/>
-          </a:xfrm>
-          <a:prstGeom prst="line">
-            <a:avLst/>
-          </a:prstGeom>
-          <a:ln w="12700">
-            <a:solidFill>
-              <a:srgbClr val="D1D5DB"/>
-            </a:solidFill>
-            <a:prstDash val="solid"/>
-          </a:ln>
-        </p:spPr>
-      </p:sp>
-      <p:sp>
-        <p:nvSpPr>
-          <p:cNvPr id="22" name="trends-divider-two"/>
-          <p:cNvSpPr/>
-          <p:nvPr/>
-        </p:nvSpPr>
-        <p:spPr>
-          <a:xfrm>
-            <a:off x="5791200" y="6680200"/>
-            <a:ext cx="4673600" cy="9144"/>
-          </a:xfrm>
-          <a:prstGeom prst="line">
-            <a:avLst/>
-          </a:prstGeom>
-          <a:ln w="12700">
-            <a:solidFill>
-              <a:srgbClr val="D1D5DB"/>
-            </a:solidFill>
-            <a:prstDash val="solid"/>
-          </a:ln>
-        </p:spPr>
-      </p:sp>
-      <p:sp>
-        <p:nvSpPr>
-          <p:cNvPr id="23" name="provider-panel-title"/>
-          <p:cNvSpPr/>
-          <p:nvPr/>
-        </p:nvSpPr>
-        <p:spPr>
-          <a:xfrm>
-            <a:off x="5791200" y="2705100"/>
-            <a:ext cx="4673600" cy="254000"/>
-          </a:xfrm>
-          <a:prstGeom prst="rect">
-            <a:avLst/>
-          </a:prstGeom>
-          <a:noFill/>
-          <a:ln/>
-        </p:spPr>
-        <p:txBody>
-          <a:bodyPr wrap="none" lIns="0" tIns="0" rIns="0" bIns="0" rtlCol="0" anchor="t"/>
-          <a:lstStyle/>
-          <a:p>
-            <a:pPr algn="l" indent="0" marL="0">
-              <a:buNone/>
-            </a:pPr>
-            <a:r>
-              <a:rPr lang="en-US" altLang="en-US" sz="1600" b="1" dirty="0">
-                <a:solidFill>
-                  <a:srgbClr val="111111"/>
-                </a:solidFill>
-                <a:latin typeface="Inter" pitchFamily="34" charset="0"/>
-                <a:ea typeface="Inter" pitchFamily="34" charset="-122"/>
-                <a:cs typeface="Inter" pitchFamily="34" charset="-120"/>
-              </a:rPr>
-              <a:t>Provider recovery</a:t>
-            </a:r>
-            <a:endParaRPr lang="en-US" sz="1600" dirty="0"/>
-          </a:p>
-        </p:txBody>
-      </p:sp>
-      <p:sp>
-        <p:nvSpPr>
-          <p:cNvPr id="24" name="provider-panel-copy"/>
-          <p:cNvSpPr/>
-          <p:nvPr/>
-        </p:nvSpPr>
-        <p:spPr>
-          <a:xfrm>
-            <a:off x="5791200" y="3098800"/>
-            <a:ext cx="4673600" cy="1257300"/>
+          <p:cNvPr id="22" name="controls-title"/>
+          <p:cNvSpPr/>
+          <p:nvPr/>
+        </p:nvSpPr>
+        <p:spPr>
+          <a:xfrm>
+            <a:off x="1371600" y="6921500"/>
+            <a:ext cx="3810000" cy="533400"/>
           </a:xfrm>
           <a:prstGeom prst="rect">
             <a:avLst/>
@@ -2363,23 +2245,32 @@
           <a:p>
             <a:pPr algn="l" indent="0" marL="0">
               <a:lnSpc>
-                <a:spcPts val="1680"/>
+                <a:spcPts val="1870"/>
               </a:lnSpc>
               <a:buNone/>
             </a:pPr>
             <a:r>
-              <a:rPr lang="en-US" altLang="en-US" sz="1400" b="1" dirty="0">
-                <a:solidFill>
-                  <a:srgbClr val="00875A"/>
+              <a:rPr lang="en-US" altLang="en-US" sz="1700" b="1" dirty="0">
+                <a:solidFill>
+                  <a:srgbClr val="111111"/>
                 </a:solidFill>
                 <a:latin typeface="Inter" pitchFamily="34" charset="0"/>
                 <a:ea typeface="Inter" pitchFamily="34" charset="-122"/>
                 <a:cs typeface="Inter" pitchFamily="34" charset="-120"/>
               </a:rPr>
-              <a:t>OBSERVED</a:t>
-            </a:r>
-            <a:r>
-              <a:rPr lang="en-US" altLang="en-US" sz="1400" dirty="0">
+              <a:t>Collateral &amp; Valuation</a:t>
+            </a:r>
+            <a:endParaRPr lang="en-US" sz="1700" dirty="0"/>
+          </a:p>
+          <a:p>
+            <a:pPr algn="l" indent="0" marL="0">
+              <a:lnSpc>
+                <a:spcPts val="1870"/>
+              </a:lnSpc>
+              <a:buNone/>
+            </a:pPr>
+            <a:r>
+              <a:rPr lang="en-US" altLang="en-US" sz="1700" b="1" dirty="0">
                 <a:solidFill>
                   <a:srgbClr val="111111"/>
                 </a:solidFill>
@@ -2387,122 +2278,22 @@
                 <a:ea typeface="Inter" pitchFamily="34" charset="-122"/>
                 <a:cs typeface="Inter" pitchFamily="34" charset="-120"/>
               </a:rPr>
-              <a:t> A configuration update interrupted transfers, cards, onchain services and institutional settlement. </a:t>
-            </a:r>
-            <a:r>
-              <a:rPr lang="en-US" altLang="en-US" sz="1400" b="1" dirty="0">
-                <a:solidFill>
-                  <a:srgbClr val="111111"/>
-                </a:solidFill>
-                <a:latin typeface="Inter" pitchFamily="34" charset="0"/>
-                <a:ea typeface="Inter" pitchFamily="34" charset="-122"/>
-                <a:cs typeface="Inter" pitchFamily="34" charset="-120"/>
-              </a:rPr>
-              <a:t>2LoD assessment:</a:t>
-            </a:r>
-            <a:r>
-              <a:rPr lang="en-US" altLang="en-US" sz="1400" dirty="0">
-                <a:solidFill>
-                  <a:srgbClr val="111111"/>
-                </a:solidFill>
-                <a:latin typeface="Inter" pitchFamily="34" charset="0"/>
-                <a:ea typeface="Inter" pitchFamily="34" charset="-122"/>
-                <a:cs typeface="Inter" pitchFamily="34" charset="-120"/>
-              </a:rPr>
-              <a:t> routine change and recovery route shared operational infrastructure; test independent recovery and pre-authorise safe emergency access.</a:t>
-            </a:r>
-            <a:endParaRPr lang="en-US" sz="1400" dirty="0"/>
+              <a:t>Controls</a:t>
+            </a:r>
+            <a:endParaRPr lang="en-US" sz="1700" dirty="0"/>
           </a:p>
         </p:txBody>
       </p:sp>
       <p:sp>
         <p:nvSpPr>
-          <p:cNvPr id="25" name="fraud-panel-title"/>
-          <p:cNvSpPr/>
-          <p:nvPr/>
-        </p:nvSpPr>
-        <p:spPr>
-          <a:xfrm>
-            <a:off x="5791200" y="4787900"/>
-            <a:ext cx="2159000" cy="254000"/>
-          </a:xfrm>
-          <a:prstGeom prst="rect">
-            <a:avLst/>
-          </a:prstGeom>
-          <a:noFill/>
-          <a:ln/>
-        </p:spPr>
-        <p:txBody>
-          <a:bodyPr wrap="none" lIns="0" tIns="0" rIns="0" bIns="0" rtlCol="0" anchor="t"/>
-          <a:lstStyle/>
-          <a:p>
-            <a:pPr algn="l" indent="0" marL="0">
-              <a:buNone/>
-            </a:pPr>
-            <a:r>
-              <a:rPr lang="en-US" altLang="en-US" sz="1600" b="1" dirty="0">
-                <a:solidFill>
-                  <a:srgbClr val="111111"/>
-                </a:solidFill>
-                <a:latin typeface="Inter" pitchFamily="34" charset="0"/>
-                <a:ea typeface="Inter" pitchFamily="34" charset="-122"/>
-                <a:cs typeface="Inter" pitchFamily="34" charset="-120"/>
-              </a:rPr>
-              <a:t>Fraud and laundering</a:t>
-            </a:r>
-            <a:endParaRPr lang="en-US" sz="1600" dirty="0"/>
-          </a:p>
-        </p:txBody>
-      </p:sp>
-      <p:sp>
-        <p:nvSpPr>
-          <p:cNvPr id="26" name="fraud-panel-metric"/>
-          <p:cNvSpPr/>
-          <p:nvPr/>
-        </p:nvSpPr>
-        <p:spPr>
-          <a:xfrm>
-            <a:off x="8255000" y="4775200"/>
-            <a:ext cx="2209800" cy="304800"/>
-          </a:xfrm>
-          <a:prstGeom prst="rect">
-            <a:avLst/>
-          </a:prstGeom>
-          <a:noFill/>
-          <a:ln/>
-        </p:spPr>
-        <p:txBody>
-          <a:bodyPr wrap="none" lIns="0" tIns="0" rIns="0" bIns="0" rtlCol="0" anchor="t"/>
-          <a:lstStyle/>
-          <a:p>
-            <a:pPr algn="r" indent="0" marL="0">
-              <a:buNone/>
-            </a:pPr>
-            <a:r>
-              <a:rPr lang="en-US" altLang="en-US" sz="2100" dirty="0">
-                <a:solidFill>
-                  <a:srgbClr val="00875A"/>
-                </a:solidFill>
-                <a:latin typeface="Inter" pitchFamily="34" charset="0"/>
-                <a:ea typeface="Inter" pitchFamily="34" charset="-122"/>
-                <a:cs typeface="Inter" pitchFamily="34" charset="-120"/>
-              </a:rPr>
-              <a:t>USD 25m</a:t>
-            </a:r>
-            <a:endParaRPr lang="en-US" sz="2100" dirty="0"/>
-          </a:p>
-        </p:txBody>
-      </p:sp>
-      <p:sp>
-        <p:nvSpPr>
-          <p:cNvPr id="27" name="fraud-panel-copy"/>
-          <p:cNvSpPr/>
-          <p:nvPr/>
-        </p:nvSpPr>
-        <p:spPr>
-          <a:xfrm>
-            <a:off x="5791200" y="5207000"/>
-            <a:ext cx="4673600" cy="1295400"/>
+          <p:cNvPr id="23" name="controls-copy"/>
+          <p:cNvSpPr/>
+          <p:nvPr/>
+        </p:nvSpPr>
+        <p:spPr>
+          <a:xfrm>
+            <a:off x="406400" y="7899400"/>
+            <a:ext cx="4775200" cy="762000"/>
           </a:xfrm>
           <a:prstGeom prst="rect">
             <a:avLst/>
@@ -2518,23 +2309,51 @@
           <a:p>
             <a:pPr algn="l" indent="0" marL="0">
               <a:lnSpc>
-                <a:spcPts val="1680"/>
+                <a:spcPts val="1534"/>
               </a:lnSpc>
               <a:buNone/>
             </a:pPr>
             <a:r>
-              <a:rPr lang="en-US" altLang="en-US" sz="1400" b="1" dirty="0">
-                <a:solidFill>
-                  <a:srgbClr val="00875A"/>
+              <a:rPr lang="en-US" altLang="en-US" sz="1300" dirty="0">
+                <a:solidFill>
+                  <a:srgbClr val="111111"/>
                 </a:solidFill>
                 <a:latin typeface="Inter" pitchFamily="34" charset="0"/>
                 <a:ea typeface="Inter" pitchFamily="34" charset="-122"/>
                 <a:cs typeface="Inter" pitchFamily="34" charset="-120"/>
               </a:rPr>
-              <a:t>OBSERVED</a:t>
-            </a:r>
-            <a:r>
-              <a:rPr lang="en-US" altLang="en-US" sz="1400" dirty="0">
+              <a:t>Intraday valuation, margin-call execution and collateral mobility require continuous testing as client flows change across venues and custody providers.</a:t>
+            </a:r>
+            <a:endParaRPr lang="en-US" sz="1300" dirty="0"/>
+          </a:p>
+        </p:txBody>
+      </p:sp>
+      <p:sp>
+        <p:nvSpPr>
+          <p:cNvPr id="24" name="trends-heading"/>
+          <p:cNvSpPr/>
+          <p:nvPr/>
+        </p:nvSpPr>
+        <p:spPr>
+          <a:xfrm>
+            <a:off x="5765800" y="1803400"/>
+            <a:ext cx="3302000" cy="355600"/>
+          </a:xfrm>
+          <a:prstGeom prst="rect">
+            <a:avLst/>
+          </a:prstGeom>
+          <a:noFill/>
+          <a:ln/>
+        </p:spPr>
+        <p:txBody>
+          <a:bodyPr wrap="none" lIns="0" tIns="0" rIns="0" bIns="0" rtlCol="0" anchor="t"/>
+          <a:lstStyle/>
+          <a:p>
+            <a:pPr algn="l" indent="0" marL="0">
+              <a:buNone/>
+            </a:pPr>
+            <a:r>
+              <a:rPr lang="en-US" altLang="en-US" sz="2100" b="1" dirty="0">
                 <a:solidFill>
                   <a:srgbClr val="111111"/>
                 </a:solidFill>
@@ -2542,192 +2361,15 @@
                 <a:ea typeface="Inter" pitchFamily="34" charset="-122"/>
                 <a:cs typeface="Inter" pitchFamily="34" charset="-120"/>
               </a:rPr>
-              <a:t> United States action sought funds tied to international crypto-investment fraud and laundering. </a:t>
-            </a:r>
-            <a:r>
-              <a:rPr lang="en-US" altLang="en-US" sz="1400" b="1" dirty="0">
-                <a:solidFill>
-                  <a:srgbClr val="111111"/>
-                </a:solidFill>
-                <a:latin typeface="Inter" pitchFamily="34" charset="0"/>
-                <a:ea typeface="Inter" pitchFamily="34" charset="-122"/>
-                <a:cs typeface="Inter" pitchFamily="34" charset="-120"/>
-              </a:rPr>
-              <a:t>2LoD assessment:</a:t>
-            </a:r>
-            <a:r>
-              <a:rPr lang="en-US" altLang="en-US" sz="1400" dirty="0">
-                <a:solidFill>
-                  <a:srgbClr val="111111"/>
-                </a:solidFill>
-                <a:latin typeface="Inter" pitchFamily="34" charset="0"/>
-                <a:ea typeface="Inter" pitchFamily="34" charset="-122"/>
-                <a:cs typeface="Inter" pitchFamily="34" charset="-120"/>
-              </a:rPr>
-              <a:t> align scam detection, payment holds, transaction monitoring and client intervention from onboarding to outbound transfer.</a:t>
-            </a:r>
-            <a:endParaRPr lang="en-US" sz="1400" dirty="0"/>
-          </a:p>
-        </p:txBody>
-      </p:sp>
-      <p:sp>
-        <p:nvSpPr>
-          <p:cNvPr id="28" name="settlement-panel-title"/>
-          <p:cNvSpPr/>
-          <p:nvPr/>
-        </p:nvSpPr>
-        <p:spPr>
-          <a:xfrm>
-            <a:off x="5791200" y="6896100"/>
-            <a:ext cx="4673600" cy="254000"/>
-          </a:xfrm>
-          <a:prstGeom prst="rect">
-            <a:avLst/>
-          </a:prstGeom>
-          <a:noFill/>
-          <a:ln/>
-        </p:spPr>
-        <p:txBody>
-          <a:bodyPr wrap="none" lIns="0" tIns="0" rIns="0" bIns="0" rtlCol="0" anchor="t"/>
-          <a:lstStyle/>
-          <a:p>
-            <a:pPr algn="l" indent="0" marL="0">
-              <a:buNone/>
-            </a:pPr>
-            <a:r>
-              <a:rPr lang="en-US" altLang="en-US" sz="1600" b="1" dirty="0">
-                <a:solidFill>
-                  <a:srgbClr val="111111"/>
-                </a:solidFill>
-                <a:latin typeface="Inter" pitchFamily="34" charset="0"/>
-                <a:ea typeface="Inter" pitchFamily="34" charset="-122"/>
-                <a:cs typeface="Inter" pitchFamily="34" charset="-120"/>
-              </a:rPr>
-              <a:t>Tokenised settlement expansion</a:t>
-            </a:r>
-            <a:endParaRPr lang="en-US" sz="1600" dirty="0"/>
-          </a:p>
-        </p:txBody>
-      </p:sp>
-      <p:sp>
-        <p:nvSpPr>
-          <p:cNvPr id="29" name="settlement-panel-copy"/>
-          <p:cNvSpPr/>
-          <p:nvPr/>
-        </p:nvSpPr>
-        <p:spPr>
-          <a:xfrm>
-            <a:off x="5791200" y="7289800"/>
-            <a:ext cx="4673600" cy="1371600"/>
-          </a:xfrm>
-          <a:prstGeom prst="rect">
-            <a:avLst/>
-          </a:prstGeom>
-          <a:noFill/>
-          <a:ln/>
-        </p:spPr>
-        <p:txBody>
-          <a:bodyPr wrap="square" lIns="0" tIns="0" rIns="0" bIns="0" rtlCol="0" anchor="t">
-            <a:normAutofit/>
-          </a:bodyPr>
-          <a:lstStyle/>
-          <a:p>
-            <a:pPr algn="l" indent="0" marL="0">
-              <a:lnSpc>
-                <a:spcPts val="1680"/>
-              </a:lnSpc>
-              <a:buNone/>
-            </a:pPr>
-            <a:r>
-              <a:rPr lang="en-US" altLang="en-US" sz="1400" b="1" dirty="0">
-                <a:solidFill>
-                  <a:srgbClr val="00875A"/>
-                </a:solidFill>
-                <a:latin typeface="Inter" pitchFamily="34" charset="0"/>
-                <a:ea typeface="Inter" pitchFamily="34" charset="-122"/>
-                <a:cs typeface="Inter" pitchFamily="34" charset="-120"/>
-              </a:rPr>
-              <a:t>OBSERVED</a:t>
-            </a:r>
-            <a:r>
-              <a:rPr lang="en-US" altLang="en-US" sz="1400" dirty="0">
-                <a:solidFill>
-                  <a:srgbClr val="111111"/>
-                </a:solidFill>
-                <a:latin typeface="Inter" pitchFamily="34" charset="0"/>
-                <a:ea typeface="Inter" pitchFamily="34" charset="-122"/>
-                <a:cs typeface="Inter" pitchFamily="34" charset="-120"/>
-              </a:rPr>
-              <a:t> A planned connection extends tokenised-deposit settlement across institutions. </a:t>
-            </a:r>
-            <a:r>
-              <a:rPr lang="en-US" altLang="en-US" sz="1400" b="1" dirty="0">
-                <a:solidFill>
-                  <a:srgbClr val="111111"/>
-                </a:solidFill>
-                <a:latin typeface="Inter" pitchFamily="34" charset="0"/>
-                <a:ea typeface="Inter" pitchFamily="34" charset="-122"/>
-                <a:cs typeface="Inter" pitchFamily="34" charset="-120"/>
-              </a:rPr>
-              <a:t>2LoD assessment:</a:t>
-            </a:r>
-            <a:r>
-              <a:rPr lang="en-US" altLang="en-US" sz="1400" dirty="0">
-                <a:solidFill>
-                  <a:srgbClr val="111111"/>
-                </a:solidFill>
-                <a:latin typeface="Inter" pitchFamily="34" charset="0"/>
-                <a:ea typeface="Inter" pitchFamily="34" charset="-122"/>
-                <a:cs typeface="Inter" pitchFamily="34" charset="-120"/>
-              </a:rPr>
-              <a:t> routing and settlement dependencies can transmit disruption; certify interoperability, screening, liquidity, finality and exit controls before production.</a:t>
-            </a:r>
-            <a:endParaRPr lang="en-US" sz="1400" dirty="0"/>
-          </a:p>
-        </p:txBody>
-      </p:sp>
-      <p:sp>
-        <p:nvSpPr>
-          <p:cNvPr id="30" name="regulation-heading"/>
-          <p:cNvSpPr/>
-          <p:nvPr/>
-        </p:nvSpPr>
-        <p:spPr>
-          <a:xfrm>
-            <a:off x="11074400" y="2082800"/>
-            <a:ext cx="3937000" cy="342900"/>
-          </a:xfrm>
-          <a:prstGeom prst="rect">
-            <a:avLst/>
-          </a:prstGeom>
-          <a:noFill/>
-          <a:ln/>
-        </p:spPr>
-        <p:txBody>
-          <a:bodyPr wrap="none" lIns="0" tIns="0" rIns="0" bIns="0" rtlCol="0" anchor="t"/>
-          <a:lstStyle/>
-          <a:p>
-            <a:pPr algn="l" indent="0" marL="0">
-              <a:buNone/>
-            </a:pPr>
-            <a:r>
-              <a:rPr lang="en-US" altLang="en-US" sz="2000" b="1" dirty="0">
-                <a:solidFill>
-                  <a:srgbClr val="111111"/>
-                </a:solidFill>
-                <a:latin typeface="Inter" pitchFamily="34" charset="0"/>
-                <a:ea typeface="Inter" pitchFamily="34" charset="-122"/>
-                <a:cs typeface="Inter" pitchFamily="34" charset="-120"/>
-              </a:rPr>
-              <a:t>REGULATORY MANDATES</a:t>
-            </a:r>
-            <a:endParaRPr lang="en-US" sz="2000" dirty="0"/>
+              <a:t>KEY TRENDS</a:t>
+            </a:r>
+            <a:endParaRPr lang="en-US" sz="2100" dirty="0"/>
           </a:p>
         </p:txBody>
       </p:sp>
       <p:pic>
         <p:nvPicPr>
-          <p:cNvPr id="31" name="regulation-icon" descr="preencoded.png">    </p:cNvPr>
+          <p:cNvPr id="25" name="trends-column-icon" descr="preencoded.png">    </p:cNvPr>
           <p:cNvPicPr>
             <a:picLocks noChangeAspect="1"/>
           </p:cNvPicPr>
@@ -2741,8 +2383,8 @@
         </p:blipFill>
         <p:spPr>
           <a:xfrm>
-            <a:off x="15316200" y="2057400"/>
-            <a:ext cx="330200" cy="330200"/>
+            <a:off x="9982200" y="1778000"/>
+            <a:ext cx="355600" cy="355600"/>
           </a:xfrm>
           <a:prstGeom prst="rect">
             <a:avLst/>
@@ -2751,14 +2393,14 @@
       </p:pic>
       <p:sp>
         <p:nvSpPr>
-          <p:cNvPr id="32" name="regulation-underline"/>
-          <p:cNvSpPr/>
-          <p:nvPr/>
-        </p:nvSpPr>
-        <p:spPr>
-          <a:xfrm>
-            <a:off x="11074400" y="2514600"/>
-            <a:ext cx="4775200" cy="9144"/>
+          <p:cNvPr id="26" name="trends-rule"/>
+          <p:cNvSpPr/>
+          <p:nvPr/>
+        </p:nvSpPr>
+        <p:spPr>
+          <a:xfrm>
+            <a:off x="5765800" y="2260600"/>
+            <a:ext cx="4699000" cy="9144"/>
           </a:xfrm>
           <a:prstGeom prst="line">
             <a:avLst/>
@@ -2773,14 +2415,14 @@
       </p:sp>
       <p:sp>
         <p:nvSpPr>
-          <p:cNvPr id="33" name="regulation-divider-one"/>
-          <p:cNvSpPr/>
-          <p:nvPr/>
-        </p:nvSpPr>
-        <p:spPr>
-          <a:xfrm>
-            <a:off x="11074400" y="4572000"/>
-            <a:ext cx="4775200" cy="9144"/>
+          <p:cNvPr id="27" name="trends-divider-one"/>
+          <p:cNvSpPr/>
+          <p:nvPr/>
+        </p:nvSpPr>
+        <p:spPr>
+          <a:xfrm>
+            <a:off x="5765800" y="4572000"/>
+            <a:ext cx="4699000" cy="9144"/>
           </a:xfrm>
           <a:prstGeom prst="line">
             <a:avLst/>
@@ -2795,14 +2437,14 @@
       </p:sp>
       <p:sp>
         <p:nvSpPr>
-          <p:cNvPr id="34" name="regulation-divider-two"/>
-          <p:cNvSpPr/>
-          <p:nvPr/>
-        </p:nvSpPr>
-        <p:spPr>
-          <a:xfrm>
-            <a:off x="11074400" y="6680200"/>
-            <a:ext cx="4775200" cy="9144"/>
+          <p:cNvPr id="28" name="trends-divider-two"/>
+          <p:cNvSpPr/>
+          <p:nvPr/>
+        </p:nvSpPr>
+        <p:spPr>
+          <a:xfrm>
+            <a:off x="5765800" y="6705600"/>
+            <a:ext cx="4699000" cy="9144"/>
           </a:xfrm>
           <a:prstGeom prst="line">
             <a:avLst/>
@@ -2815,55 +2457,40 @@
           </a:ln>
         </p:spPr>
       </p:sp>
-      <p:sp>
-        <p:nvSpPr>
-          <p:cNvPr id="35" name="stablecoin-panel-title"/>
-          <p:cNvSpPr/>
-          <p:nvPr/>
-        </p:nvSpPr>
-        <p:spPr>
-          <a:xfrm>
-            <a:off x="11074400" y="2705100"/>
-            <a:ext cx="4775200" cy="254000"/>
-          </a:xfrm>
-          <a:prstGeom prst="rect">
-            <a:avLst/>
-          </a:prstGeom>
-          <a:noFill/>
-          <a:ln/>
-        </p:spPr>
-        <p:txBody>
-          <a:bodyPr wrap="none" lIns="0" tIns="0" rIns="0" bIns="0" rtlCol="0" anchor="t"/>
-          <a:lstStyle/>
-          <a:p>
-            <a:pPr algn="l" indent="0" marL="0">
-              <a:buNone/>
-            </a:pPr>
-            <a:r>
-              <a:rPr lang="en-US" altLang="en-US" sz="1500" b="1" dirty="0">
-                <a:solidFill>
-                  <a:srgbClr val="00875A"/>
-                </a:solidFill>
-                <a:latin typeface="Inter" pitchFamily="34" charset="0"/>
-                <a:ea typeface="Inter" pitchFamily="34" charset="-122"/>
-                <a:cs typeface="Inter" pitchFamily="34" charset="-120"/>
-              </a:rPr>
-              <a:t>PROPOSAL | PAYMENT STABLECOINS</a:t>
-            </a:r>
-            <a:endParaRPr lang="en-US" sz="1500" dirty="0"/>
-          </a:p>
-        </p:txBody>
-      </p:sp>
-      <p:sp>
-        <p:nvSpPr>
-          <p:cNvPr id="36" name="stablecoin-panel-copy"/>
-          <p:cNvSpPr/>
-          <p:nvPr/>
-        </p:nvSpPr>
-        <p:spPr>
-          <a:xfrm>
-            <a:off x="11074400" y="3098800"/>
-            <a:ext cx="4775200" cy="1257300"/>
+      <p:pic>
+        <p:nvPicPr>
+          <p:cNvPr id="29" name="recovery-icon" descr="preencoded.png">    </p:cNvPr>
+          <p:cNvPicPr>
+            <a:picLocks noChangeAspect="1"/>
+          </p:cNvPicPr>
+          <p:nvPr/>
+        </p:nvPicPr>
+        <p:blipFill>
+          <a:blip r:embed="rId6"/>
+          <a:stretch>
+            <a:fillRect/>
+          </a:stretch>
+        </p:blipFill>
+        <p:spPr>
+          <a:xfrm>
+            <a:off x="5765800" y="2679700"/>
+            <a:ext cx="990600" cy="990600"/>
+          </a:xfrm>
+          <a:prstGeom prst="rect">
+            <a:avLst/>
+          </a:prstGeom>
+        </p:spPr>
+      </p:pic>
+      <p:sp>
+        <p:nvSpPr>
+          <p:cNvPr id="30" name="recovery-title"/>
+          <p:cNvSpPr/>
+          <p:nvPr/>
+        </p:nvSpPr>
+        <p:spPr>
+          <a:xfrm>
+            <a:off x="6985000" y="2603500"/>
+            <a:ext cx="3479800" cy="558800"/>
           </a:xfrm>
           <a:prstGeom prst="rect">
             <a:avLst/>
@@ -2879,12 +2506,12 @@
           <a:p>
             <a:pPr algn="l" indent="0" marL="0">
               <a:lnSpc>
-                <a:spcPts val="1680"/>
+                <a:spcPts val="1944"/>
               </a:lnSpc>
               <a:buNone/>
             </a:pPr>
             <a:r>
-              <a:rPr lang="en-US" altLang="en-US" sz="1400" dirty="0">
+              <a:rPr lang="en-US" altLang="en-US" sz="1800" b="1" dirty="0">
                 <a:solidFill>
                   <a:srgbClr val="111111"/>
                 </a:solidFill>
@@ -2892,10 +2519,19 @@
                 <a:ea typeface="Inter" pitchFamily="34" charset="-122"/>
                 <a:cs typeface="Inter" pitchFamily="34" charset="-120"/>
               </a:rPr>
-              <a:t>Treasury proposed payment-stablecoin issuance and distribution rules. </a:t>
-            </a:r>
-            <a:r>
-              <a:rPr lang="en-US" altLang="en-US" sz="1400" b="1" dirty="0">
+              <a:t>Service Interruption</a:t>
+            </a:r>
+            <a:endParaRPr lang="en-US" sz="1800" dirty="0"/>
+          </a:p>
+          <a:p>
+            <a:pPr algn="l" indent="0" marL="0">
+              <a:lnSpc>
+                <a:spcPts val="1944"/>
+              </a:lnSpc>
+              <a:buNone/>
+            </a:pPr>
+            <a:r>
+              <a:rPr lang="en-US" altLang="en-US" sz="1800" b="1" dirty="0">
                 <a:solidFill>
                   <a:srgbClr val="111111"/>
                 </a:solidFill>
@@ -2903,72 +2539,22 @@
                 <a:ea typeface="Inter" pitchFamily="34" charset="-122"/>
                 <a:cs typeface="Inter" pitchFamily="34" charset="-120"/>
               </a:rPr>
-              <a:t>2LoD assessment:</a:t>
-            </a:r>
-            <a:r>
-              <a:rPr lang="en-US" altLang="en-US" sz="1400" dirty="0">
-                <a:solidFill>
-                  <a:srgbClr val="111111"/>
-                </a:solidFill>
-                <a:latin typeface="Inter" pitchFamily="34" charset="0"/>
-                <a:ea typeface="Inter" pitchFamily="34" charset="-122"/>
-                <a:cs typeface="Inter" pitchFamily="34" charset="-120"/>
-              </a:rPr>
-              <a:t> map products, issuers, reserve access, wallets, disclosures and cross-border eligibility. Proposal only; no binding implementation is asserted.</a:t>
-            </a:r>
-            <a:endParaRPr lang="en-US" sz="1400" dirty="0"/>
+              <a:t>and Recovery</a:t>
+            </a:r>
+            <a:endParaRPr lang="en-US" sz="1800" dirty="0"/>
           </a:p>
         </p:txBody>
       </p:sp>
       <p:sp>
         <p:nvSpPr>
-          <p:cNvPr id="37" name="offerings-panel-title"/>
-          <p:cNvSpPr/>
-          <p:nvPr/>
-        </p:nvSpPr>
-        <p:spPr>
-          <a:xfrm>
-            <a:off x="11074400" y="4787900"/>
-            <a:ext cx="4775200" cy="254000"/>
-          </a:xfrm>
-          <a:prstGeom prst="rect">
-            <a:avLst/>
-          </a:prstGeom>
-          <a:noFill/>
-          <a:ln/>
-        </p:spPr>
-        <p:txBody>
-          <a:bodyPr wrap="none" lIns="0" tIns="0" rIns="0" bIns="0" rtlCol="0" anchor="t"/>
-          <a:lstStyle/>
-          <a:p>
-            <a:pPr algn="l" indent="0" marL="0">
-              <a:buNone/>
-            </a:pPr>
-            <a:r>
-              <a:rPr lang="en-US" altLang="en-US" sz="1500" b="1" dirty="0">
-                <a:solidFill>
-                  <a:srgbClr val="00875A"/>
-                </a:solidFill>
-                <a:latin typeface="Inter" pitchFamily="34" charset="0"/>
-                <a:ea typeface="Inter" pitchFamily="34" charset="-122"/>
-                <a:cs typeface="Inter" pitchFamily="34" charset="-120"/>
-              </a:rPr>
-              <a:t>PROPOSAL | TOKEN OFFERINGS</a:t>
-            </a:r>
-            <a:endParaRPr lang="en-US" sz="1500" dirty="0"/>
-          </a:p>
-        </p:txBody>
-      </p:sp>
-      <p:sp>
-        <p:nvSpPr>
-          <p:cNvPr id="38" name="offerings-panel-copy"/>
-          <p:cNvSpPr/>
-          <p:nvPr/>
-        </p:nvSpPr>
-        <p:spPr>
-          <a:xfrm>
-            <a:off x="11074400" y="5207000"/>
-            <a:ext cx="4775200" cy="1295400"/>
+          <p:cNvPr id="31" name="recovery-copy"/>
+          <p:cNvSpPr/>
+          <p:nvPr/>
+        </p:nvSpPr>
+        <p:spPr>
+          <a:xfrm>
+            <a:off x="5765800" y="3835400"/>
+            <a:ext cx="4699000" cy="584200"/>
           </a:xfrm>
           <a:prstGeom prst="rect">
             <a:avLst/>
@@ -2984,12 +2570,12 @@
           <a:p>
             <a:pPr algn="l" indent="0" marL="0">
               <a:lnSpc>
-                <a:spcPts val="1680"/>
+                <a:spcPts val="1534"/>
               </a:lnSpc>
               <a:buNone/>
             </a:pPr>
             <a:r>
-              <a:rPr lang="en-US" altLang="en-US" sz="1400" dirty="0">
+              <a:rPr lang="en-US" altLang="en-US" sz="1300" dirty="0">
                 <a:solidFill>
                   <a:srgbClr val="111111"/>
                 </a:solidFill>
@@ -2997,21 +2583,101 @@
                 <a:ea typeface="Inter" pitchFamily="34" charset="-122"/>
                 <a:cs typeface="Inter" pitchFamily="34" charset="-120"/>
               </a:rPr>
-              <a:t>SEC proposed a tailored regime for specified crypto-asset investment contracts. </a:t>
-            </a:r>
-            <a:r>
-              <a:rPr lang="en-US" altLang="en-US" sz="1400" b="1" dirty="0">
-                <a:solidFill>
-                  <a:srgbClr val="111111"/>
+              <a:t>A configuration update interrupted transfers, cards, onchain services and institutional settlement. The standard rollback path relied on the impacted gateway, requiring manual recovery through a separate cloud workflow.</a:t>
+            </a:r>
+            <a:endParaRPr lang="en-US" sz="1300" dirty="0"/>
+          </a:p>
+        </p:txBody>
+      </p:sp>
+      <p:pic>
+        <p:nvPicPr>
+          <p:cNvPr id="32" name="fraud-icon" descr="preencoded.png">    </p:cNvPr>
+          <p:cNvPicPr>
+            <a:picLocks noChangeAspect="1"/>
+          </p:cNvPicPr>
+          <p:nvPr/>
+        </p:nvPicPr>
+        <p:blipFill>
+          <a:blip r:embed="rId7"/>
+          <a:stretch>
+            <a:fillRect/>
+          </a:stretch>
+        </p:blipFill>
+        <p:spPr>
+          <a:xfrm>
+            <a:off x="5765800" y="5041900"/>
+            <a:ext cx="914400" cy="914400"/>
+          </a:xfrm>
+          <a:prstGeom prst="rect">
+            <a:avLst/>
+          </a:prstGeom>
+        </p:spPr>
+      </p:pic>
+      <p:sp>
+        <p:nvSpPr>
+          <p:cNvPr id="33" name="fraud-metric"/>
+          <p:cNvSpPr/>
+          <p:nvPr/>
+        </p:nvSpPr>
+        <p:spPr>
+          <a:xfrm>
+            <a:off x="6959600" y="5016500"/>
+            <a:ext cx="3505200" cy="393700"/>
+          </a:xfrm>
+          <a:prstGeom prst="rect">
+            <a:avLst/>
+          </a:prstGeom>
+          <a:noFill/>
+          <a:ln/>
+        </p:spPr>
+        <p:txBody>
+          <a:bodyPr wrap="none" lIns="0" tIns="0" rIns="0" bIns="0" rtlCol="0" anchor="t"/>
+          <a:lstStyle/>
+          <a:p>
+            <a:pPr algn="l" indent="0" marL="0">
+              <a:buNone/>
+            </a:pPr>
+            <a:r>
+              <a:rPr lang="en-US" altLang="en-US" sz="2600" dirty="0">
+                <a:solidFill>
+                  <a:srgbClr val="00875A"/>
                 </a:solidFill>
                 <a:latin typeface="Inter" pitchFamily="34" charset="0"/>
                 <a:ea typeface="Inter" pitchFamily="34" charset="-122"/>
                 <a:cs typeface="Inter" pitchFamily="34" charset="-120"/>
               </a:rPr>
-              <a:t>2LoD assessment:</a:t>
-            </a:r>
-            <a:r>
-              <a:rPr lang="en-US" altLang="en-US" sz="1400" dirty="0">
+              <a:t>USD 25m</a:t>
+            </a:r>
+            <a:endParaRPr lang="en-US" sz="2600" dirty="0"/>
+          </a:p>
+        </p:txBody>
+      </p:sp>
+      <p:sp>
+        <p:nvSpPr>
+          <p:cNvPr id="34" name="fraud-title"/>
+          <p:cNvSpPr/>
+          <p:nvPr/>
+        </p:nvSpPr>
+        <p:spPr>
+          <a:xfrm>
+            <a:off x="6959600" y="5486400"/>
+            <a:ext cx="3505200" cy="266700"/>
+          </a:xfrm>
+          <a:prstGeom prst="rect">
+            <a:avLst/>
+          </a:prstGeom>
+          <a:noFill/>
+          <a:ln/>
+        </p:spPr>
+        <p:txBody>
+          <a:bodyPr wrap="none" lIns="0" tIns="0" rIns="0" bIns="0" rtlCol="0" anchor="t"/>
+          <a:lstStyle/>
+          <a:p>
+            <a:pPr algn="l" indent="0" marL="0">
+              <a:buNone/>
+            </a:pPr>
+            <a:r>
+              <a:rPr lang="en-US" altLang="en-US" sz="1700" b="1" dirty="0">
                 <a:solidFill>
                   <a:srgbClr val="111111"/>
                 </a:solidFill>
@@ -3019,61 +2685,22 @@
                 <a:ea typeface="Inter" pitchFamily="34" charset="-122"/>
                 <a:cs typeface="Inter" pitchFamily="34" charset="-120"/>
               </a:rPr>
-              <a:t> define classification, disclosure and distribution ownership before intermediary participation expands. Proposal only; no future requirement is assumed.</a:t>
-            </a:r>
-            <a:endParaRPr lang="en-US" sz="1400" dirty="0"/>
+              <a:t>Fraud &amp; Laundering</a:t>
+            </a:r>
+            <a:endParaRPr lang="en-US" sz="1700" dirty="0"/>
           </a:p>
         </p:txBody>
       </p:sp>
       <p:sp>
         <p:nvSpPr>
-          <p:cNvPr id="39" name="segregation-panel-title"/>
-          <p:cNvSpPr/>
-          <p:nvPr/>
-        </p:nvSpPr>
-        <p:spPr>
-          <a:xfrm>
-            <a:off x="11074400" y="6896100"/>
-            <a:ext cx="4775200" cy="254000"/>
-          </a:xfrm>
-          <a:prstGeom prst="rect">
-            <a:avLst/>
-          </a:prstGeom>
-          <a:noFill/>
-          <a:ln/>
-        </p:spPr>
-        <p:txBody>
-          <a:bodyPr wrap="none" lIns="0" tIns="0" rIns="0" bIns="0" rtlCol="0" anchor="t"/>
-          <a:lstStyle/>
-          <a:p>
-            <a:pPr algn="l" indent="0" marL="0">
-              <a:buNone/>
-            </a:pPr>
-            <a:r>
-              <a:rPr lang="en-US" altLang="en-US" sz="1500" b="1" dirty="0">
-                <a:solidFill>
-                  <a:srgbClr val="00875A"/>
-                </a:solidFill>
-                <a:latin typeface="Inter" pitchFamily="34" charset="0"/>
-                <a:ea typeface="Inter" pitchFamily="34" charset="-122"/>
-                <a:cs typeface="Inter" pitchFamily="34" charset="-120"/>
-              </a:rPr>
-              <a:t>ENFORCEMENT | CLIENT-ASSET SEGREGATION</a:t>
-            </a:r>
-            <a:endParaRPr lang="en-US" sz="1500" dirty="0"/>
-          </a:p>
-        </p:txBody>
-      </p:sp>
-      <p:sp>
-        <p:nvSpPr>
-          <p:cNvPr id="40" name="segregation-panel-copy"/>
-          <p:cNvSpPr/>
-          <p:nvPr/>
-        </p:nvSpPr>
-        <p:spPr>
-          <a:xfrm>
-            <a:off x="11074400" y="7289800"/>
-            <a:ext cx="4775200" cy="1371600"/>
+          <p:cNvPr id="35" name="fraud-copy"/>
+          <p:cNvSpPr/>
+          <p:nvPr/>
+        </p:nvSpPr>
+        <p:spPr>
+          <a:xfrm>
+            <a:off x="5765800" y="6070600"/>
+            <a:ext cx="4699000" cy="482600"/>
           </a:xfrm>
           <a:prstGeom prst="rect">
             <a:avLst/>
@@ -3089,12 +2716,12 @@
           <a:p>
             <a:pPr algn="l" indent="0" marL="0">
               <a:lnSpc>
-                <a:spcPts val="1680"/>
+                <a:spcPts val="1534"/>
               </a:lnSpc>
               <a:buNone/>
             </a:pPr>
             <a:r>
-              <a:rPr lang="en-US" altLang="en-US" sz="1400" dirty="0">
+              <a:rPr lang="en-US" altLang="en-US" sz="1300" dirty="0">
                 <a:solidFill>
                   <a:srgbClr val="111111"/>
                 </a:solidFill>
@@ -3102,10 +2729,67 @@
                 <a:ea typeface="Inter" pitchFamily="34" charset="-122"/>
                 <a:cs typeface="Inter" pitchFamily="34" charset="-120"/>
               </a:rPr>
-              <a:t>FTX-related enforcement resolution reinforces the governance lessons from affiliate misuse. </a:t>
-            </a:r>
-            <a:r>
-              <a:rPr lang="en-US" altLang="en-US" sz="1400" b="1" dirty="0">
+              <a:t>Five civil forfeiture complaints sought more than USD 25m in cryptocurrency recovered during separate fraud investigations. Scam detection, payment holds and monitoring must operate consistently across transfer routes.</a:t>
+            </a:r>
+            <a:endParaRPr lang="en-US" sz="1300" dirty="0"/>
+          </a:p>
+        </p:txBody>
+      </p:sp>
+      <p:pic>
+        <p:nvPicPr>
+          <p:cNvPr id="36" name="settlement-icon" descr="preencoded.png">    </p:cNvPr>
+          <p:cNvPicPr>
+            <a:picLocks noChangeAspect="1"/>
+          </p:cNvPicPr>
+          <p:nvPr/>
+        </p:nvPicPr>
+        <p:blipFill>
+          <a:blip r:embed="rId8"/>
+          <a:stretch>
+            <a:fillRect/>
+          </a:stretch>
+        </p:blipFill>
+        <p:spPr>
+          <a:xfrm>
+            <a:off x="5765800" y="7010400"/>
+            <a:ext cx="914400" cy="914400"/>
+          </a:xfrm>
+          <a:prstGeom prst="rect">
+            <a:avLst/>
+          </a:prstGeom>
+        </p:spPr>
+      </p:pic>
+      <p:sp>
+        <p:nvSpPr>
+          <p:cNvPr id="37" name="settlement-title"/>
+          <p:cNvSpPr/>
+          <p:nvPr/>
+        </p:nvSpPr>
+        <p:spPr>
+          <a:xfrm>
+            <a:off x="6959600" y="6921500"/>
+            <a:ext cx="3505200" cy="533400"/>
+          </a:xfrm>
+          <a:prstGeom prst="rect">
+            <a:avLst/>
+          </a:prstGeom>
+          <a:noFill/>
+          <a:ln/>
+        </p:spPr>
+        <p:txBody>
+          <a:bodyPr wrap="square" lIns="0" tIns="0" rIns="0" bIns="0" rtlCol="0" anchor="t">
+            <a:normAutofit/>
+          </a:bodyPr>
+          <a:lstStyle/>
+          <a:p>
+            <a:pPr algn="l" indent="0" marL="0">
+              <a:lnSpc>
+                <a:spcPts val="1944"/>
+              </a:lnSpc>
+              <a:buNone/>
+            </a:pPr>
+            <a:r>
+              <a:rPr lang="en-US" altLang="en-US" sz="1800" b="1" dirty="0">
                 <a:solidFill>
                   <a:srgbClr val="111111"/>
                 </a:solidFill>
@@ -3113,10 +2797,19 @@
                 <a:ea typeface="Inter" pitchFamily="34" charset="-122"/>
                 <a:cs typeface="Inter" pitchFamily="34" charset="-120"/>
               </a:rPr>
-              <a:t>2LoD assessment:</a:t>
-            </a:r>
-            <a:r>
-              <a:rPr lang="en-US" altLang="en-US" sz="1400" dirty="0">
+              <a:t>Tokenised Settlement</a:t>
+            </a:r>
+            <a:endParaRPr lang="en-US" sz="1800" dirty="0"/>
+          </a:p>
+          <a:p>
+            <a:pPr algn="l" indent="0" marL="0">
+              <a:lnSpc>
+                <a:spcPts val="1944"/>
+              </a:lnSpc>
+              <a:buNone/>
+            </a:pPr>
+            <a:r>
+              <a:rPr lang="en-US" altLang="en-US" sz="1800" b="1" dirty="0">
                 <a:solidFill>
                   <a:srgbClr val="111111"/>
                 </a:solidFill>
@@ -3124,10 +2817,43 @@
                 <a:ea typeface="Inter" pitchFamily="34" charset="-122"/>
                 <a:cs typeface="Inter" pitchFamily="34" charset="-120"/>
               </a:rPr>
-              <a:t> independent governance, client-asset segregation and internal risk-transfer controls remain decision conditions. Bank-specific loss scenario: </a:t>
-            </a:r>
-            <a:r>
-              <a:rPr lang="en-US" altLang="en-US" sz="1400" b="1" dirty="0">
+              <a:t>Networks</a:t>
+            </a:r>
+            <a:endParaRPr lang="en-US" sz="1800" dirty="0"/>
+          </a:p>
+        </p:txBody>
+      </p:sp>
+      <p:sp>
+        <p:nvSpPr>
+          <p:cNvPr id="38" name="settlement-copy"/>
+          <p:cNvSpPr/>
+          <p:nvPr/>
+        </p:nvSpPr>
+        <p:spPr>
+          <a:xfrm>
+            <a:off x="5765800" y="8026400"/>
+            <a:ext cx="4699000" cy="635000"/>
+          </a:xfrm>
+          <a:prstGeom prst="rect">
+            <a:avLst/>
+          </a:prstGeom>
+          <a:noFill/>
+          <a:ln/>
+        </p:spPr>
+        <p:txBody>
+          <a:bodyPr wrap="square" lIns="0" tIns="0" rIns="0" bIns="0" rtlCol="0" anchor="t">
+            <a:normAutofit/>
+          </a:bodyPr>
+          <a:lstStyle/>
+          <a:p>
+            <a:pPr algn="l" indent="0" marL="0">
+              <a:lnSpc>
+                <a:spcPts val="1534"/>
+              </a:lnSpc>
+              <a:buNone/>
+            </a:pPr>
+            <a:r>
+              <a:rPr lang="en-US" altLang="en-US" sz="1300" dirty="0">
                 <a:solidFill>
                   <a:srgbClr val="111111"/>
                 </a:solidFill>
@@ -3135,10 +2861,38 @@
                 <a:ea typeface="Inter" pitchFamily="34" charset="-122"/>
                 <a:cs typeface="Inter" pitchFamily="34" charset="-120"/>
               </a:rPr>
-              <a:t>NEEDS_REVIEW</a:t>
-            </a:r>
-            <a:r>
-              <a:rPr lang="en-US" altLang="en-US" sz="1400" dirty="0">
+              <a:t>Planned tokenised-deposit settlement connectivity extends cross-border routing dependencies. Interoperability, finality, screening, liquidity and exit arrangements require testing before production.</a:t>
+            </a:r>
+            <a:endParaRPr lang="en-US" sz="1300" dirty="0"/>
+          </a:p>
+        </p:txBody>
+      </p:sp>
+      <p:sp>
+        <p:nvSpPr>
+          <p:cNvPr id="39" name="regulation-heading"/>
+          <p:cNvSpPr/>
+          <p:nvPr/>
+        </p:nvSpPr>
+        <p:spPr>
+          <a:xfrm>
+            <a:off x="11099800" y="1803400"/>
+            <a:ext cx="3937000" cy="355600"/>
+          </a:xfrm>
+          <a:prstGeom prst="rect">
+            <a:avLst/>
+          </a:prstGeom>
+          <a:noFill/>
+          <a:ln/>
+        </p:spPr>
+        <p:txBody>
+          <a:bodyPr wrap="none" lIns="0" tIns="0" rIns="0" bIns="0" rtlCol="0" anchor="t"/>
+          <a:lstStyle/>
+          <a:p>
+            <a:pPr algn="l" indent="0" marL="0">
+              <a:buNone/>
+            </a:pPr>
+            <a:r>
+              <a:rPr lang="en-US" altLang="en-US" sz="2100" b="1" dirty="0">
                 <a:solidFill>
                   <a:srgbClr val="111111"/>
                 </a:solidFill>
@@ -3146,9 +2900,660 @@
                 <a:ea typeface="Inter" pitchFamily="34" charset="-122"/>
                 <a:cs typeface="Inter" pitchFamily="34" charset="-120"/>
               </a:rPr>
-              <a:t>.</a:t>
+              <a:t>REGULATORY MANDATES</a:t>
+            </a:r>
+            <a:endParaRPr lang="en-US" sz="2100" dirty="0"/>
+          </a:p>
+        </p:txBody>
+      </p:sp>
+      <p:pic>
+        <p:nvPicPr>
+          <p:cNvPr id="40" name="regulation-column-icon" descr="preencoded.png">    </p:cNvPr>
+          <p:cNvPicPr>
+            <a:picLocks noChangeAspect="1"/>
+          </p:cNvPicPr>
+          <p:nvPr/>
+        </p:nvPicPr>
+        <p:blipFill>
+          <a:blip r:embed="rId9"/>
+          <a:stretch>
+            <a:fillRect/>
+          </a:stretch>
+        </p:blipFill>
+        <p:spPr>
+          <a:xfrm>
+            <a:off x="15316200" y="1778000"/>
+            <a:ext cx="355600" cy="355600"/>
+          </a:xfrm>
+          <a:prstGeom prst="rect">
+            <a:avLst/>
+          </a:prstGeom>
+        </p:spPr>
+      </p:pic>
+      <p:sp>
+        <p:nvSpPr>
+          <p:cNvPr id="41" name="regulation-rule"/>
+          <p:cNvSpPr/>
+          <p:nvPr/>
+        </p:nvSpPr>
+        <p:spPr>
+          <a:xfrm>
+            <a:off x="11099800" y="2260600"/>
+            <a:ext cx="4749800" cy="9144"/>
+          </a:xfrm>
+          <a:prstGeom prst="line">
+            <a:avLst/>
+          </a:prstGeom>
+          <a:ln w="25400">
+            <a:solidFill>
+              <a:srgbClr val="00875A"/>
+            </a:solidFill>
+            <a:prstDash val="solid"/>
+          </a:ln>
+        </p:spPr>
+      </p:sp>
+      <p:sp>
+        <p:nvSpPr>
+          <p:cNvPr id="42" name="regulation-divider-one"/>
+          <p:cNvSpPr/>
+          <p:nvPr/>
+        </p:nvSpPr>
+        <p:spPr>
+          <a:xfrm>
+            <a:off x="11099800" y="4572000"/>
+            <a:ext cx="4749800" cy="9144"/>
+          </a:xfrm>
+          <a:prstGeom prst="line">
+            <a:avLst/>
+          </a:prstGeom>
+          <a:ln w="12700">
+            <a:solidFill>
+              <a:srgbClr val="D1D5DB"/>
+            </a:solidFill>
+            <a:prstDash val="solid"/>
+          </a:ln>
+        </p:spPr>
+      </p:sp>
+      <p:sp>
+        <p:nvSpPr>
+          <p:cNvPr id="43" name="regulation-divider-two"/>
+          <p:cNvSpPr/>
+          <p:nvPr/>
+        </p:nvSpPr>
+        <p:spPr>
+          <a:xfrm>
+            <a:off x="11099800" y="6705600"/>
+            <a:ext cx="4749800" cy="9144"/>
+          </a:xfrm>
+          <a:prstGeom prst="line">
+            <a:avLst/>
+          </a:prstGeom>
+          <a:ln w="12700">
+            <a:solidFill>
+              <a:srgbClr val="D1D5DB"/>
+            </a:solidFill>
+            <a:prstDash val="solid"/>
+          </a:ln>
+        </p:spPr>
+      </p:sp>
+      <p:pic>
+        <p:nvPicPr>
+          <p:cNvPr id="44" name="stablecoin-icon" descr="preencoded.png">    </p:cNvPr>
+          <p:cNvPicPr>
+            <a:picLocks noChangeAspect="1"/>
+          </p:cNvPicPr>
+          <p:nvPr/>
+        </p:nvPicPr>
+        <p:blipFill>
+          <a:blip r:embed="rId10"/>
+          <a:stretch>
+            <a:fillRect/>
+          </a:stretch>
+        </p:blipFill>
+        <p:spPr>
+          <a:xfrm>
+            <a:off x="11099800" y="2679700"/>
+            <a:ext cx="990600" cy="990600"/>
+          </a:xfrm>
+          <a:prstGeom prst="rect">
+            <a:avLst/>
+          </a:prstGeom>
+        </p:spPr>
+      </p:pic>
+      <p:sp>
+        <p:nvSpPr>
+          <p:cNvPr id="45" name="stablecoin-status"/>
+          <p:cNvSpPr/>
+          <p:nvPr/>
+        </p:nvSpPr>
+        <p:spPr>
+          <a:xfrm>
+            <a:off x="12344400" y="2603500"/>
+            <a:ext cx="3505200" cy="254000"/>
+          </a:xfrm>
+          <a:prstGeom prst="rect">
+            <a:avLst/>
+          </a:prstGeom>
+          <a:noFill/>
+          <a:ln/>
+        </p:spPr>
+        <p:txBody>
+          <a:bodyPr wrap="none" lIns="0" tIns="0" rIns="0" bIns="0" rtlCol="0" anchor="t"/>
+          <a:lstStyle/>
+          <a:p>
+            <a:pPr algn="l" indent="0" marL="0">
+              <a:buNone/>
+            </a:pPr>
+            <a:r>
+              <a:rPr lang="en-US" altLang="en-US" sz="1400" b="1" dirty="0">
+                <a:solidFill>
+                  <a:srgbClr val="00875A"/>
+                </a:solidFill>
+                <a:latin typeface="Inter" pitchFamily="34" charset="0"/>
+                <a:ea typeface="Inter" pitchFamily="34" charset="-122"/>
+                <a:cs typeface="Inter" pitchFamily="34" charset="-120"/>
+              </a:rPr>
+              <a:t>PROPOSAL</a:t>
             </a:r>
             <a:endParaRPr lang="en-US" sz="1400" dirty="0"/>
+          </a:p>
+        </p:txBody>
+      </p:sp>
+      <p:sp>
+        <p:nvSpPr>
+          <p:cNvPr id="46" name="stablecoin-title"/>
+          <p:cNvSpPr/>
+          <p:nvPr/>
+        </p:nvSpPr>
+        <p:spPr>
+          <a:xfrm>
+            <a:off x="12344400" y="2921000"/>
+            <a:ext cx="3505200" cy="533400"/>
+          </a:xfrm>
+          <a:prstGeom prst="rect">
+            <a:avLst/>
+          </a:prstGeom>
+          <a:noFill/>
+          <a:ln/>
+        </p:spPr>
+        <p:txBody>
+          <a:bodyPr wrap="square" lIns="0" tIns="0" rIns="0" bIns="0" rtlCol="0" anchor="t">
+            <a:normAutofit/>
+          </a:bodyPr>
+          <a:lstStyle/>
+          <a:p>
+            <a:pPr algn="l" indent="0" marL="0">
+              <a:lnSpc>
+                <a:spcPts val="1944"/>
+              </a:lnSpc>
+              <a:buNone/>
+            </a:pPr>
+            <a:r>
+              <a:rPr lang="en-US" altLang="en-US" sz="1800" b="1" dirty="0">
+                <a:solidFill>
+                  <a:srgbClr val="111111"/>
+                </a:solidFill>
+                <a:latin typeface="Inter" pitchFamily="34" charset="0"/>
+                <a:ea typeface="Inter" pitchFamily="34" charset="-122"/>
+                <a:cs typeface="Inter" pitchFamily="34" charset="-120"/>
+              </a:rPr>
+              <a:t>Payment</a:t>
+            </a:r>
+            <a:endParaRPr lang="en-US" sz="1800" dirty="0"/>
+          </a:p>
+          <a:p>
+            <a:pPr algn="l" indent="0" marL="0">
+              <a:lnSpc>
+                <a:spcPts val="1944"/>
+              </a:lnSpc>
+              <a:buNone/>
+            </a:pPr>
+            <a:r>
+              <a:rPr lang="en-US" altLang="en-US" sz="1800" b="1" dirty="0">
+                <a:solidFill>
+                  <a:srgbClr val="111111"/>
+                </a:solidFill>
+                <a:latin typeface="Inter" pitchFamily="34" charset="0"/>
+                <a:ea typeface="Inter" pitchFamily="34" charset="-122"/>
+                <a:cs typeface="Inter" pitchFamily="34" charset="-120"/>
+              </a:rPr>
+              <a:t>Stablecoins</a:t>
+            </a:r>
+            <a:endParaRPr lang="en-US" sz="1800" dirty="0"/>
+          </a:p>
+        </p:txBody>
+      </p:sp>
+      <p:sp>
+        <p:nvSpPr>
+          <p:cNvPr id="47" name="stablecoin-copy"/>
+          <p:cNvSpPr/>
+          <p:nvPr/>
+        </p:nvSpPr>
+        <p:spPr>
+          <a:xfrm>
+            <a:off x="11099800" y="3835400"/>
+            <a:ext cx="4749800" cy="584200"/>
+          </a:xfrm>
+          <a:prstGeom prst="rect">
+            <a:avLst/>
+          </a:prstGeom>
+          <a:noFill/>
+          <a:ln/>
+        </p:spPr>
+        <p:txBody>
+          <a:bodyPr wrap="square" lIns="0" tIns="0" rIns="0" bIns="0" rtlCol="0" anchor="t">
+            <a:normAutofit/>
+          </a:bodyPr>
+          <a:lstStyle/>
+          <a:p>
+            <a:pPr algn="l" indent="0" marL="0">
+              <a:lnSpc>
+                <a:spcPts val="1534"/>
+              </a:lnSpc>
+              <a:buNone/>
+            </a:pPr>
+            <a:r>
+              <a:rPr lang="en-US" altLang="en-US" sz="1300" dirty="0">
+                <a:solidFill>
+                  <a:srgbClr val="111111"/>
+                </a:solidFill>
+                <a:latin typeface="Inter" pitchFamily="34" charset="0"/>
+                <a:ea typeface="Inter" pitchFamily="34" charset="-122"/>
+                <a:cs typeface="Inter" pitchFamily="34" charset="-120"/>
+              </a:rPr>
+              <a:t>Treasury proposed rules for payment-stablecoin issuance, offering and sale. Product inventory, issuers, reserve access, wallet controls, disclosures and cross-border eligibility require defined ownership.</a:t>
+            </a:r>
+            <a:endParaRPr lang="en-US" sz="1300" dirty="0"/>
+          </a:p>
+        </p:txBody>
+      </p:sp>
+      <p:pic>
+        <p:nvPicPr>
+          <p:cNvPr id="48" name="offering-icon" descr="preencoded.png">    </p:cNvPr>
+          <p:cNvPicPr>
+            <a:picLocks noChangeAspect="1"/>
+          </p:cNvPicPr>
+          <p:nvPr/>
+        </p:nvPicPr>
+        <p:blipFill>
+          <a:blip r:embed="rId11"/>
+          <a:stretch>
+            <a:fillRect/>
+          </a:stretch>
+        </p:blipFill>
+        <p:spPr>
+          <a:xfrm>
+            <a:off x="11099800" y="5041900"/>
+            <a:ext cx="914400" cy="914400"/>
+          </a:xfrm>
+          <a:prstGeom prst="rect">
+            <a:avLst/>
+          </a:prstGeom>
+        </p:spPr>
+      </p:pic>
+      <p:sp>
+        <p:nvSpPr>
+          <p:cNvPr id="49" name="offering-status"/>
+          <p:cNvSpPr/>
+          <p:nvPr/>
+        </p:nvSpPr>
+        <p:spPr>
+          <a:xfrm>
+            <a:off x="12268200" y="5003800"/>
+            <a:ext cx="3581400" cy="254000"/>
+          </a:xfrm>
+          <a:prstGeom prst="rect">
+            <a:avLst/>
+          </a:prstGeom>
+          <a:noFill/>
+          <a:ln/>
+        </p:spPr>
+        <p:txBody>
+          <a:bodyPr wrap="none" lIns="0" tIns="0" rIns="0" bIns="0" rtlCol="0" anchor="t"/>
+          <a:lstStyle/>
+          <a:p>
+            <a:pPr algn="l" indent="0" marL="0">
+              <a:buNone/>
+            </a:pPr>
+            <a:r>
+              <a:rPr lang="en-US" altLang="en-US" sz="1400" b="1" dirty="0">
+                <a:solidFill>
+                  <a:srgbClr val="00875A"/>
+                </a:solidFill>
+                <a:latin typeface="Inter" pitchFamily="34" charset="0"/>
+                <a:ea typeface="Inter" pitchFamily="34" charset="-122"/>
+                <a:cs typeface="Inter" pitchFamily="34" charset="-120"/>
+              </a:rPr>
+              <a:t>PROPOSAL</a:t>
+            </a:r>
+            <a:endParaRPr lang="en-US" sz="1400" dirty="0"/>
+          </a:p>
+        </p:txBody>
+      </p:sp>
+      <p:sp>
+        <p:nvSpPr>
+          <p:cNvPr id="50" name="offering-title"/>
+          <p:cNvSpPr/>
+          <p:nvPr/>
+        </p:nvSpPr>
+        <p:spPr>
+          <a:xfrm>
+            <a:off x="12268200" y="5321300"/>
+            <a:ext cx="3581400" cy="266700"/>
+          </a:xfrm>
+          <a:prstGeom prst="rect">
+            <a:avLst/>
+          </a:prstGeom>
+          <a:noFill/>
+          <a:ln/>
+        </p:spPr>
+        <p:txBody>
+          <a:bodyPr wrap="none" lIns="0" tIns="0" rIns="0" bIns="0" rtlCol="0" anchor="t"/>
+          <a:lstStyle/>
+          <a:p>
+            <a:pPr algn="l" indent="0" marL="0">
+              <a:buNone/>
+            </a:pPr>
+            <a:r>
+              <a:rPr lang="en-US" altLang="en-US" sz="1700" b="1" dirty="0">
+                <a:solidFill>
+                  <a:srgbClr val="111111"/>
+                </a:solidFill>
+                <a:latin typeface="Inter" pitchFamily="34" charset="0"/>
+                <a:ea typeface="Inter" pitchFamily="34" charset="-122"/>
+                <a:cs typeface="Inter" pitchFamily="34" charset="-120"/>
+              </a:rPr>
+              <a:t>Token Offerings</a:t>
+            </a:r>
+            <a:endParaRPr lang="en-US" sz="1700" dirty="0"/>
+          </a:p>
+        </p:txBody>
+      </p:sp>
+      <p:sp>
+        <p:nvSpPr>
+          <p:cNvPr id="51" name="timeline-line"/>
+          <p:cNvSpPr/>
+          <p:nvPr/>
+        </p:nvSpPr>
+        <p:spPr>
+          <a:xfrm>
+            <a:off x="12268200" y="5829300"/>
+            <a:ext cx="3175000" cy="9144"/>
+          </a:xfrm>
+          <a:prstGeom prst="line">
+            <a:avLst/>
+          </a:prstGeom>
+          <a:ln w="12700">
+            <a:solidFill>
+              <a:srgbClr val="111111"/>
+            </a:solidFill>
+            <a:prstDash val="solid"/>
+            <a:tailEnd type="triangle"/>
+          </a:ln>
+        </p:spPr>
+      </p:sp>
+      <p:sp>
+        <p:nvSpPr>
+          <p:cNvPr id="52" name="timeline-dot-one"/>
+          <p:cNvSpPr/>
+          <p:nvPr/>
+        </p:nvSpPr>
+        <p:spPr>
+          <a:xfrm>
+            <a:off x="12293600" y="5727700"/>
+            <a:ext cx="203200" cy="203200"/>
+          </a:xfrm>
+          <a:prstGeom prst="ellipse">
+            <a:avLst/>
+          </a:prstGeom>
+          <a:solidFill>
+            <a:srgbClr val="00875A"/>
+          </a:solidFill>
+          <a:ln w="12700">
+            <a:solidFill>
+              <a:srgbClr val="111111"/>
+            </a:solidFill>
+            <a:prstDash val="solid"/>
+          </a:ln>
+        </p:spPr>
+      </p:sp>
+      <p:sp>
+        <p:nvSpPr>
+          <p:cNvPr id="53" name="timeline-dot-two"/>
+          <p:cNvSpPr/>
+          <p:nvPr/>
+        </p:nvSpPr>
+        <p:spPr>
+          <a:xfrm>
+            <a:off x="13538200" y="5727700"/>
+            <a:ext cx="203200" cy="203200"/>
+          </a:xfrm>
+          <a:prstGeom prst="ellipse">
+            <a:avLst/>
+          </a:prstGeom>
+          <a:solidFill>
+            <a:srgbClr val="00875A"/>
+          </a:solidFill>
+          <a:ln w="12700">
+            <a:solidFill>
+              <a:srgbClr val="111111"/>
+            </a:solidFill>
+            <a:prstDash val="solid"/>
+          </a:ln>
+        </p:spPr>
+      </p:sp>
+      <p:sp>
+        <p:nvSpPr>
+          <p:cNvPr id="54" name="timeline-dot-three"/>
+          <p:cNvSpPr/>
+          <p:nvPr/>
+        </p:nvSpPr>
+        <p:spPr>
+          <a:xfrm>
+            <a:off x="14782800" y="5727700"/>
+            <a:ext cx="203200" cy="203200"/>
+          </a:xfrm>
+          <a:prstGeom prst="ellipse">
+            <a:avLst/>
+          </a:prstGeom>
+          <a:solidFill>
+            <a:srgbClr val="00875A"/>
+          </a:solidFill>
+          <a:ln w="12700">
+            <a:solidFill>
+              <a:srgbClr val="111111"/>
+            </a:solidFill>
+            <a:prstDash val="solid"/>
+          </a:ln>
+        </p:spPr>
+      </p:sp>
+      <p:sp>
+        <p:nvSpPr>
+          <p:cNvPr id="55" name="timeline-copy"/>
+          <p:cNvSpPr/>
+          <p:nvPr/>
+        </p:nvSpPr>
+        <p:spPr>
+          <a:xfrm>
+            <a:off x="11099800" y="6134100"/>
+            <a:ext cx="4749800" cy="419100"/>
+          </a:xfrm>
+          <a:prstGeom prst="rect">
+            <a:avLst/>
+          </a:prstGeom>
+          <a:noFill/>
+          <a:ln/>
+        </p:spPr>
+        <p:txBody>
+          <a:bodyPr wrap="square" lIns="0" tIns="0" rIns="0" bIns="0" rtlCol="0" anchor="t">
+            <a:normAutofit/>
+          </a:bodyPr>
+          <a:lstStyle/>
+          <a:p>
+            <a:pPr algn="l" indent="0" marL="0">
+              <a:lnSpc>
+                <a:spcPts val="1534"/>
+              </a:lnSpc>
+              <a:buNone/>
+            </a:pPr>
+            <a:r>
+              <a:rPr lang="en-US" altLang="en-US" sz="1300" dirty="0">
+                <a:solidFill>
+                  <a:srgbClr val="111111"/>
+                </a:solidFill>
+                <a:latin typeface="Inter" pitchFamily="34" charset="0"/>
+                <a:ea typeface="Inter" pitchFamily="34" charset="-122"/>
+                <a:cs typeface="Inter" pitchFamily="34" charset="-120"/>
+              </a:rPr>
+              <a:t>The SEC proposal includes tailored offering exemptions, disclosures and specified reporting conditions. Classification and disclosure ownership require defined control gates.</a:t>
+            </a:r>
+            <a:endParaRPr lang="en-US" sz="1300" dirty="0"/>
+          </a:p>
+        </p:txBody>
+      </p:sp>
+      <p:pic>
+        <p:nvPicPr>
+          <p:cNvPr id="56" name="segregation-icon" descr="preencoded.png">    </p:cNvPr>
+          <p:cNvPicPr>
+            <a:picLocks noChangeAspect="1"/>
+          </p:cNvPicPr>
+          <p:nvPr/>
+        </p:nvPicPr>
+        <p:blipFill>
+          <a:blip r:embed="rId12"/>
+          <a:stretch>
+            <a:fillRect/>
+          </a:stretch>
+        </p:blipFill>
+        <p:spPr>
+          <a:xfrm>
+            <a:off x="11099800" y="7010400"/>
+            <a:ext cx="914400" cy="914400"/>
+          </a:xfrm>
+          <a:prstGeom prst="rect">
+            <a:avLst/>
+          </a:prstGeom>
+        </p:spPr>
+      </p:pic>
+      <p:sp>
+        <p:nvSpPr>
+          <p:cNvPr id="57" name="segregation-status"/>
+          <p:cNvSpPr/>
+          <p:nvPr/>
+        </p:nvSpPr>
+        <p:spPr>
+          <a:xfrm>
+            <a:off x="12268200" y="6921500"/>
+            <a:ext cx="3581400" cy="254000"/>
+          </a:xfrm>
+          <a:prstGeom prst="rect">
+            <a:avLst/>
+          </a:prstGeom>
+          <a:noFill/>
+          <a:ln/>
+        </p:spPr>
+        <p:txBody>
+          <a:bodyPr wrap="none" lIns="0" tIns="0" rIns="0" bIns="0" rtlCol="0" anchor="t"/>
+          <a:lstStyle/>
+          <a:p>
+            <a:pPr algn="l" indent="0" marL="0">
+              <a:buNone/>
+            </a:pPr>
+            <a:r>
+              <a:rPr lang="en-US" altLang="en-US" sz="1400" b="1" dirty="0">
+                <a:solidFill>
+                  <a:srgbClr val="00875A"/>
+                </a:solidFill>
+                <a:latin typeface="Inter" pitchFamily="34" charset="0"/>
+                <a:ea typeface="Inter" pitchFamily="34" charset="-122"/>
+                <a:cs typeface="Inter" pitchFamily="34" charset="-120"/>
+              </a:rPr>
+              <a:t>ENFORCEMENT</a:t>
+            </a:r>
+            <a:endParaRPr lang="en-US" sz="1400" dirty="0"/>
+          </a:p>
+        </p:txBody>
+      </p:sp>
+      <p:sp>
+        <p:nvSpPr>
+          <p:cNvPr id="58" name="segregation-title"/>
+          <p:cNvSpPr/>
+          <p:nvPr/>
+        </p:nvSpPr>
+        <p:spPr>
+          <a:xfrm>
+            <a:off x="12268200" y="7239000"/>
+            <a:ext cx="3581400" cy="266700"/>
+          </a:xfrm>
+          <a:prstGeom prst="rect">
+            <a:avLst/>
+          </a:prstGeom>
+          <a:noFill/>
+          <a:ln/>
+        </p:spPr>
+        <p:txBody>
+          <a:bodyPr wrap="none" lIns="0" tIns="0" rIns="0" bIns="0" rtlCol="0" anchor="t"/>
+          <a:lstStyle/>
+          <a:p>
+            <a:pPr algn="l" indent="0" marL="0">
+              <a:buNone/>
+            </a:pPr>
+            <a:r>
+              <a:rPr lang="en-US" altLang="en-US" sz="1700" b="1" dirty="0">
+                <a:solidFill>
+                  <a:srgbClr val="111111"/>
+                </a:solidFill>
+                <a:latin typeface="Inter" pitchFamily="34" charset="0"/>
+                <a:ea typeface="Inter" pitchFamily="34" charset="-122"/>
+                <a:cs typeface="Inter" pitchFamily="34" charset="-120"/>
+              </a:rPr>
+              <a:t>FTX / Alameda Resolution</a:t>
+            </a:r>
+            <a:endParaRPr lang="en-US" sz="1700" dirty="0"/>
+          </a:p>
+        </p:txBody>
+      </p:sp>
+      <p:sp>
+        <p:nvSpPr>
+          <p:cNvPr id="59" name="segregation-copy"/>
+          <p:cNvSpPr/>
+          <p:nvPr/>
+        </p:nvSpPr>
+        <p:spPr>
+          <a:xfrm>
+            <a:off x="11099800" y="8026400"/>
+            <a:ext cx="4749800" cy="635000"/>
+          </a:xfrm>
+          <a:prstGeom prst="rect">
+            <a:avLst/>
+          </a:prstGeom>
+          <a:noFill/>
+          <a:ln/>
+        </p:spPr>
+        <p:txBody>
+          <a:bodyPr wrap="square" lIns="0" tIns="0" rIns="0" bIns="0" rtlCol="0" anchor="t">
+            <a:normAutofit/>
+          </a:bodyPr>
+          <a:lstStyle/>
+          <a:p>
+            <a:pPr algn="l" indent="0" marL="0">
+              <a:lnSpc>
+                <a:spcPts val="1534"/>
+              </a:lnSpc>
+              <a:buNone/>
+            </a:pPr>
+            <a:r>
+              <a:rPr lang="en-US" altLang="en-US" sz="1300" dirty="0">
+                <a:solidFill>
+                  <a:srgbClr val="111111"/>
+                </a:solidFill>
+                <a:latin typeface="Inter" pitchFamily="34" charset="0"/>
+                <a:ea typeface="Inter" pitchFamily="34" charset="-122"/>
+                <a:cs typeface="Inter" pitchFamily="34" charset="-120"/>
+              </a:rPr>
+              <a:t>CFTC supplemental consent orders resolved actions against former Alameda CEO Caroline Ellison and FTX / Alameda co-founder Gary Wang. The release cites trading and registration bans and a USD 11.020bn criminal forfeiture order.</a:t>
+            </a:r>
+            <a:endParaRPr lang="en-US" sz="1300" dirty="0"/>
           </a:p>
         </p:txBody>
       </p:sp>

</xml_diff>